<commit_message>
Documentation and homepage for 1.42.1 (D/T)
Co-Authored-By: Claude Opus 5.5 <noreply@anthropic.com>
Claude-Session: https://claude.ai/code/session_01X3i1BkBkXRM4JocUMi2KX3
</commit_message>
<xml_diff>
--- a/docs/Geocaching-Map-Custom-Tile-Layers-Presentasjon.pptx
+++ b/docs/Geocaching-Map-Custom-Tile-Layers-Presentasjon.pptx
@@ -121,13 +121,13 @@
   <p:extLst>
     <p:ext uri="{521415D9-36F7-43E2-AB2F-B90AF26B5E84}">
       <p14:sectionLst xmlns:p14="http://schemas.microsoft.com/office/powerpoint/2010/main">
-        <p14:section name="Innledning" id="{9bc17edf-14e2-69c1-2f53-6ee35f03784d}">
+        <p14:section name="Innledning" id="{8a699bff-e02a-219f-1bb2-d0929e28021a}">
           <p14:sldIdLst>
             <p14:sldId id="256"/>
             <p14:sldId id="257"/>
           </p14:sldIdLst>
         </p14:section>
-        <p14:section name="Funksjoner" id="{5a92d590-3116-469e-bfe2-5c8662a08819}">
+        <p14:section name="Funksjoner" id="{cbef5b9a-ad0b-c82f-4a40-645a2893c4f9}">
           <p14:sldIdLst>
             <p14:sldId id="258"/>
             <p14:sldId id="259"/>
@@ -140,14 +140,14 @@
             <p14:sldId id="266"/>
           </p14:sldIdLst>
         </p14:section>
-        <p14:section name="Teknikk" id="{1c957b44-160e-92e8-6dbb-49974bc45f3c}">
+        <p14:section name="Teknikk" id="{1677caf1-c50f-6121-4915-d32a830833f8}">
           <p14:sldIdLst>
             <p14:sldId id="267"/>
             <p14:sldId id="268"/>
             <p14:sldId id="269"/>
           </p14:sldIdLst>
         </p14:section>
-        <p14:section name="Avslutning" id="{ac584423-94d4-9304-9caf-4d7e692b6326}">
+        <p14:section name="Avslutning" id="{6b80d537-c68b-7710-6ffa-de399115a460}">
           <p14:sldIdLst>
             <p14:sldId id="270"/>
           </p14:sldIdLst>
@@ -2063,7 +2063,7 @@
                   <a:schemeClr val="accent4"/>
                 </a:solidFill>
               </a:rPr>
-              <a:t>Geocaching Map – Custom Tile Layers · v1.41.9</a:t>
+              <a:t>Geocaching Map – Custom Tile Layers · v1.42.1</a:t>
             </a:r>
             <a:endParaRPr lang="en-US" sz="1000" dirty="0"/>
           </a:p>
@@ -2583,7 +2583,7 @@
                   <a:schemeClr val="accent5"/>
                 </a:solidFill>
               </a:rPr>
-              <a:t>Brukerskript · versjon 1.41.9 · norsk og engelsk</a:t>
+              <a:t>Brukerskript · versjon 1.42.1 · norsk og engelsk</a:t>
             </a:r>
             <a:endParaRPr lang="en-US" sz="1400" dirty="0"/>
           </a:p>
@@ -2605,8 +2605,8 @@
         </p:blipFill>
         <p:spPr>
           <a:xfrm>
-            <a:off x="8577163" y="548640"/>
-            <a:ext cx="2700133" cy="5760720"/>
+            <a:off x="8643092" y="548640"/>
+            <a:ext cx="2634203" cy="5760720"/>
           </a:xfrm>
           <a:prstGeom prst="rect">
             <a:avLst/>
@@ -7693,8 +7693,8 @@
         </p:blipFill>
         <p:spPr>
           <a:xfrm>
-            <a:off x="1083103" y="1572768"/>
-            <a:ext cx="394115" cy="4443984"/>
+            <a:off x="1095260" y="1572768"/>
+            <a:ext cx="369801" cy="4443984"/>
           </a:xfrm>
           <a:prstGeom prst="rect">
             <a:avLst/>
@@ -7754,7 +7754,7 @@
         <p:spPr>
           <a:xfrm>
             <a:off x="3227832" y="1380744"/>
-            <a:ext cx="3493008" cy="777240"/>
+            <a:ext cx="3493008" cy="667512"/>
           </a:xfrm>
           <a:prstGeom prst="rect">
             <a:avLst/>
@@ -7809,7 +7809,7 @@
         </p:nvSpPr>
         <p:spPr>
           <a:xfrm>
-            <a:off x="2514600" y="2276856"/>
+            <a:off x="2514600" y="2167128"/>
             <a:ext cx="512064" cy="512064"/>
           </a:xfrm>
           <a:prstGeom prst="ellipse">
@@ -7837,7 +7837,7 @@
         </p:blipFill>
         <p:spPr>
           <a:xfrm>
-            <a:off x="2627254" y="2389510"/>
+            <a:off x="2627254" y="2279782"/>
             <a:ext cx="286756" cy="286756"/>
           </a:xfrm>
           <a:prstGeom prst="rect">
@@ -7853,8 +7853,8 @@
         </p:nvSpPr>
         <p:spPr>
           <a:xfrm>
-            <a:off x="3227832" y="2203704"/>
-            <a:ext cx="3493008" cy="777240"/>
+            <a:off x="3227832" y="2093976"/>
+            <a:ext cx="3493008" cy="667512"/>
           </a:xfrm>
           <a:prstGeom prst="rect">
             <a:avLst/>
@@ -7909,7 +7909,7 @@
         </p:nvSpPr>
         <p:spPr>
           <a:xfrm>
-            <a:off x="2514600" y="3099816"/>
+            <a:off x="2514600" y="2880360"/>
             <a:ext cx="512064" cy="512064"/>
           </a:xfrm>
           <a:prstGeom prst="ellipse">
@@ -7937,7 +7937,7 @@
         </p:blipFill>
         <p:spPr>
           <a:xfrm>
-            <a:off x="2627254" y="3212470"/>
+            <a:off x="2627254" y="2993014"/>
             <a:ext cx="286756" cy="286756"/>
           </a:xfrm>
           <a:prstGeom prst="rect">
@@ -7953,8 +7953,8 @@
         </p:nvSpPr>
         <p:spPr>
           <a:xfrm>
-            <a:off x="3227832" y="3026664"/>
-            <a:ext cx="3493008" cy="777240"/>
+            <a:off x="3227832" y="2807208"/>
+            <a:ext cx="3493008" cy="667512"/>
           </a:xfrm>
           <a:prstGeom prst="rect">
             <a:avLst/>
@@ -8009,7 +8009,7 @@
         </p:nvSpPr>
         <p:spPr>
           <a:xfrm>
-            <a:off x="2514600" y="3922776"/>
+            <a:off x="2514600" y="3593592"/>
             <a:ext cx="512064" cy="512064"/>
           </a:xfrm>
           <a:prstGeom prst="ellipse">
@@ -8037,7 +8037,7 @@
         </p:blipFill>
         <p:spPr>
           <a:xfrm>
-            <a:off x="2627254" y="4035430"/>
+            <a:off x="2627254" y="3706246"/>
             <a:ext cx="286756" cy="286756"/>
           </a:xfrm>
           <a:prstGeom prst="rect">
@@ -8053,8 +8053,8 @@
         </p:nvSpPr>
         <p:spPr>
           <a:xfrm>
-            <a:off x="3227832" y="3849624"/>
-            <a:ext cx="3493008" cy="777240"/>
+            <a:off x="3227832" y="3520440"/>
+            <a:ext cx="3493008" cy="667512"/>
           </a:xfrm>
           <a:prstGeom prst="rect">
             <a:avLst/>
@@ -8109,7 +8109,7 @@
         </p:nvSpPr>
         <p:spPr>
           <a:xfrm>
-            <a:off x="2514600" y="4745736"/>
+            <a:off x="2514600" y="4306824"/>
             <a:ext cx="512064" cy="512064"/>
           </a:xfrm>
           <a:prstGeom prst="ellipse">
@@ -8137,7 +8137,7 @@
         </p:blipFill>
         <p:spPr>
           <a:xfrm>
-            <a:off x="2627254" y="4858390"/>
+            <a:off x="2627254" y="4419478"/>
             <a:ext cx="286756" cy="286756"/>
           </a:xfrm>
           <a:prstGeom prst="rect">
@@ -8153,8 +8153,8 @@
         </p:nvSpPr>
         <p:spPr>
           <a:xfrm>
-            <a:off x="3227832" y="4672584"/>
-            <a:ext cx="3493008" cy="777240"/>
+            <a:off x="3227832" y="4233672"/>
+            <a:ext cx="3493008" cy="667512"/>
           </a:xfrm>
           <a:prstGeom prst="rect">
             <a:avLst/>
@@ -8203,13 +8203,13 @@
       </p:sp>
       <p:sp>
         <p:nvSpPr>
-          <p:cNvPr id="13020" name="Ikon locate sirkel"/>
+          <p:cNvPr id="13020" name="Ikon dt sirkel"/>
           <p:cNvSpPr/>
           <p:nvPr/>
         </p:nvSpPr>
         <p:spPr>
           <a:xfrm>
-            <a:off x="2514600" y="5568696"/>
+            <a:off x="2514600" y="5020056"/>
             <a:ext cx="512064" cy="512064"/>
           </a:xfrm>
           <a:prstGeom prst="ellipse">
@@ -8223,7 +8223,7 @@
       </p:sp>
       <p:pic>
         <p:nvPicPr>
-          <p:cNvPr id="13021" name="Ikon locate" descr="locate">    </p:cNvPr>
+          <p:cNvPr id="13021" name="Ikon dt" descr="dt">    </p:cNvPr>
           <p:cNvPicPr>
             <a:picLocks noChangeAspect="1"/>
           </p:cNvPicPr>
@@ -8237,7 +8237,7 @@
         </p:blipFill>
         <p:spPr>
           <a:xfrm>
-            <a:off x="2627254" y="5681350"/>
+            <a:off x="2627254" y="5132710"/>
             <a:ext cx="286756" cy="286756"/>
           </a:xfrm>
           <a:prstGeom prst="rect">
@@ -8253,8 +8253,8 @@
         </p:nvSpPr>
         <p:spPr>
           <a:xfrm>
-            <a:off x="3227832" y="5495544"/>
-            <a:ext cx="3493008" cy="777240"/>
+            <a:off x="3227832" y="4946904"/>
+            <a:ext cx="3493008" cy="667512"/>
           </a:xfrm>
           <a:prstGeom prst="rect">
             <a:avLst/>
@@ -8278,7 +8278,7 @@
                   <a:schemeClr val="tx1"/>
                 </a:solidFill>
               </a:rPr>
-              <a:t>Min posisjon</a:t>
+              <a:t>D/T</a:t>
             </a:r>
             <a:endParaRPr lang="en-US" sz="1700" dirty="0"/>
           </a:p>
@@ -8295,7 +8295,7 @@
                   <a:schemeClr val="accent4"/>
                 </a:solidFill>
               </a:rPr>
-              <a:t>Med sirkel for nøyaktighet</a:t>
+              <a:t>Vanskelighet/terreng under cachene – av/på</a:t>
             </a:r>
             <a:endParaRPr lang="en-US" sz="1700" dirty="0"/>
           </a:p>
@@ -8303,13 +8303,13 @@
       </p:sp>
       <p:sp>
         <p:nvSpPr>
-          <p:cNvPr id="13023" name="Ikon home sirkel"/>
+          <p:cNvPr id="13023" name="Ikon locate sirkel"/>
           <p:cNvSpPr/>
           <p:nvPr/>
         </p:nvSpPr>
         <p:spPr>
           <a:xfrm>
-            <a:off x="7086600" y="1453896"/>
+            <a:off x="2514600" y="5733288"/>
             <a:ext cx="512064" cy="512064"/>
           </a:xfrm>
           <a:prstGeom prst="ellipse">
@@ -8323,7 +8323,7 @@
       </p:sp>
       <p:pic>
         <p:nvPicPr>
-          <p:cNvPr id="13024" name="Ikon home" descr="home">    </p:cNvPr>
+          <p:cNvPr id="13024" name="Ikon locate" descr="locate">    </p:cNvPr>
           <p:cNvPicPr>
             <a:picLocks noChangeAspect="1"/>
           </p:cNvPicPr>
@@ -8337,7 +8337,7 @@
         </p:blipFill>
         <p:spPr>
           <a:xfrm>
-            <a:off x="7199254" y="1566550"/>
+            <a:off x="2627254" y="5845942"/>
             <a:ext cx="286756" cy="286756"/>
           </a:xfrm>
           <a:prstGeom prst="rect">
@@ -8353,8 +8353,8 @@
         </p:nvSpPr>
         <p:spPr>
           <a:xfrm>
-            <a:off x="7799832" y="1380744"/>
-            <a:ext cx="3767328" cy="777240"/>
+            <a:off x="3227832" y="5660136"/>
+            <a:ext cx="3493008" cy="667512"/>
           </a:xfrm>
           <a:prstGeom prst="rect">
             <a:avLst/>
@@ -8378,7 +8378,7 @@
                   <a:schemeClr val="tx1"/>
                 </a:solidFill>
               </a:rPr>
-              <a:t>Hjem</a:t>
+              <a:t>Min posisjon</a:t>
             </a:r>
             <a:endParaRPr lang="en-US" sz="1700" dirty="0"/>
           </a:p>
@@ -8395,7 +8395,7 @@
                   <a:schemeClr val="accent4"/>
                 </a:solidFill>
               </a:rPr>
-              <a:t>Høyreklikk for å endre adressen</a:t>
+              <a:t>Med sirkel for nøyaktighet</a:t>
             </a:r>
             <a:endParaRPr lang="en-US" sz="1700" dirty="0"/>
           </a:p>
@@ -8403,13 +8403,13 @@
       </p:sp>
       <p:sp>
         <p:nvSpPr>
-          <p:cNvPr id="13026" name="Ikon expand sirkel"/>
+          <p:cNvPr id="13026" name="Ikon home sirkel"/>
           <p:cNvSpPr/>
           <p:nvPr/>
         </p:nvSpPr>
         <p:spPr>
           <a:xfrm>
-            <a:off x="7086600" y="2276856"/>
+            <a:off x="7086600" y="1453896"/>
             <a:ext cx="512064" cy="512064"/>
           </a:xfrm>
           <a:prstGeom prst="ellipse">
@@ -8423,7 +8423,7 @@
       </p:sp>
       <p:pic>
         <p:nvPicPr>
-          <p:cNvPr id="13027" name="Ikon expand" descr="expand">    </p:cNvPr>
+          <p:cNvPr id="13027" name="Ikon home" descr="home">    </p:cNvPr>
           <p:cNvPicPr>
             <a:picLocks noChangeAspect="1"/>
           </p:cNvPicPr>
@@ -8437,7 +8437,7 @@
         </p:blipFill>
         <p:spPr>
           <a:xfrm>
-            <a:off x="7199254" y="2389510"/>
+            <a:off x="7199254" y="1566550"/>
             <a:ext cx="286756" cy="286756"/>
           </a:xfrm>
           <a:prstGeom prst="rect">
@@ -8453,8 +8453,8 @@
         </p:nvSpPr>
         <p:spPr>
           <a:xfrm>
-            <a:off x="7799832" y="2203704"/>
-            <a:ext cx="3767328" cy="777240"/>
+            <a:off x="7799832" y="1380744"/>
+            <a:ext cx="3767328" cy="667512"/>
           </a:xfrm>
           <a:prstGeom prst="rect">
             <a:avLst/>
@@ -8478,7 +8478,7 @@
                   <a:schemeClr val="tx1"/>
                 </a:solidFill>
               </a:rPr>
-              <a:t>Fullskjerm</a:t>
+              <a:t>Hjem</a:t>
             </a:r>
             <a:endParaRPr lang="en-US" sz="1700" dirty="0"/>
           </a:p>
@@ -8495,7 +8495,7 @@
                   <a:schemeClr val="accent4"/>
                 </a:solidFill>
               </a:rPr>
-              <a:t>Kartet fyller hele skjermen</a:t>
+              <a:t>Høyreklikk for å endre adressen</a:t>
             </a:r>
             <a:endParaRPr lang="en-US" sz="1700" dirty="0"/>
           </a:p>
@@ -8503,13 +8503,13 @@
       </p:sp>
       <p:sp>
         <p:nvSpPr>
-          <p:cNvPr id="13029" name="Ikon eraser sirkel"/>
+          <p:cNvPr id="13029" name="Ikon expand sirkel"/>
           <p:cNvSpPr/>
           <p:nvPr/>
         </p:nvSpPr>
         <p:spPr>
           <a:xfrm>
-            <a:off x="7086600" y="3099816"/>
+            <a:off x="7086600" y="2167128"/>
             <a:ext cx="512064" cy="512064"/>
           </a:xfrm>
           <a:prstGeom prst="ellipse">
@@ -8523,7 +8523,7 @@
       </p:sp>
       <p:pic>
         <p:nvPicPr>
-          <p:cNvPr id="13030" name="Ikon eraser" descr="eraser">    </p:cNvPr>
+          <p:cNvPr id="13030" name="Ikon expand" descr="expand">    </p:cNvPr>
           <p:cNvPicPr>
             <a:picLocks noChangeAspect="1"/>
           </p:cNvPicPr>
@@ -8537,7 +8537,7 @@
         </p:blipFill>
         <p:spPr>
           <a:xfrm>
-            <a:off x="7199254" y="3212470"/>
+            <a:off x="7199254" y="2279782"/>
             <a:ext cx="286756" cy="286756"/>
           </a:xfrm>
           <a:prstGeom prst="rect">
@@ -8553,8 +8553,8 @@
         </p:nvSpPr>
         <p:spPr>
           <a:xfrm>
-            <a:off x="7799832" y="3026664"/>
-            <a:ext cx="3767328" cy="777240"/>
+            <a:off x="7799832" y="2093976"/>
+            <a:ext cx="3767328" cy="667512"/>
           </a:xfrm>
           <a:prstGeom prst="rect">
             <a:avLst/>
@@ -8578,7 +8578,7 @@
                   <a:schemeClr val="tx1"/>
                 </a:solidFill>
               </a:rPr>
-              <a:t>Fjern tegninger</a:t>
+              <a:t>Fullskjerm</a:t>
             </a:r>
             <a:endParaRPr lang="en-US" sz="1700" dirty="0"/>
           </a:p>
@@ -8595,7 +8595,7 @@
                   <a:schemeClr val="accent4"/>
                 </a:solidFill>
               </a:rPr>
-              <a:t>Merker, målinger og sirkler</a:t>
+              <a:t>Kartet fyller hele skjermen</a:t>
             </a:r>
             <a:endParaRPr lang="en-US" sz="1700" dirty="0"/>
           </a:p>
@@ -8603,13 +8603,13 @@
       </p:sp>
       <p:sp>
         <p:nvSpPr>
-          <p:cNvPr id="13032" name="Ikon eyeoff sirkel"/>
+          <p:cNvPr id="13032" name="Ikon eraser sirkel"/>
           <p:cNvSpPr/>
           <p:nvPr/>
         </p:nvSpPr>
         <p:spPr>
           <a:xfrm>
-            <a:off x="7086600" y="3922776"/>
+            <a:off x="7086600" y="2880360"/>
             <a:ext cx="512064" cy="512064"/>
           </a:xfrm>
           <a:prstGeom prst="ellipse">
@@ -8623,7 +8623,7 @@
       </p:sp>
       <p:pic>
         <p:nvPicPr>
-          <p:cNvPr id="13033" name="Ikon eyeoff" descr="eyeoff">    </p:cNvPr>
+          <p:cNvPr id="13033" name="Ikon eraser" descr="eraser">    </p:cNvPr>
           <p:cNvPicPr>
             <a:picLocks noChangeAspect="1"/>
           </p:cNvPicPr>
@@ -8637,7 +8637,7 @@
         </p:blipFill>
         <p:spPr>
           <a:xfrm>
-            <a:off x="7199254" y="4035430"/>
+            <a:off x="7199254" y="2993014"/>
             <a:ext cx="286756" cy="286756"/>
           </a:xfrm>
           <a:prstGeom prst="rect">
@@ -8653,8 +8653,8 @@
         </p:nvSpPr>
         <p:spPr>
           <a:xfrm>
-            <a:off x="7799832" y="3849624"/>
-            <a:ext cx="3767328" cy="777240"/>
+            <a:off x="7799832" y="2807208"/>
+            <a:ext cx="3767328" cy="667512"/>
           </a:xfrm>
           <a:prstGeom prst="rect">
             <a:avLst/>
@@ -8678,7 +8678,7 @@
                   <a:schemeClr val="tx1"/>
                 </a:solidFill>
               </a:rPr>
-              <a:t>Skjul geocacher</a:t>
+              <a:t>Fjern tegninger</a:t>
             </a:r>
             <a:endParaRPr lang="en-US" sz="1700" dirty="0"/>
           </a:p>
@@ -8695,7 +8695,7 @@
                   <a:schemeClr val="accent4"/>
                 </a:solidFill>
               </a:rPr>
-              <a:t>Rent kart – klikk igjen for å vise dem</a:t>
+              <a:t>Merker, målinger og sirkler</a:t>
             </a:r>
             <a:endParaRPr lang="en-US" sz="1700" dirty="0"/>
           </a:p>
@@ -8703,13 +8703,13 @@
       </p:sp>
       <p:sp>
         <p:nvSpPr>
-          <p:cNvPr id="13035" name="Ikon heart sirkel"/>
+          <p:cNvPr id="13035" name="Ikon eyeoff sirkel"/>
           <p:cNvSpPr/>
           <p:nvPr/>
         </p:nvSpPr>
         <p:spPr>
           <a:xfrm>
-            <a:off x="7086600" y="4745736"/>
+            <a:off x="7086600" y="3593592"/>
             <a:ext cx="512064" cy="512064"/>
           </a:xfrm>
           <a:prstGeom prst="ellipse">
@@ -8723,7 +8723,7 @@
       </p:sp>
       <p:pic>
         <p:nvPicPr>
-          <p:cNvPr id="13036" name="Ikon heart" descr="heart">    </p:cNvPr>
+          <p:cNvPr id="13036" name="Ikon eyeoff" descr="eyeoff">    </p:cNvPr>
           <p:cNvPicPr>
             <a:picLocks noChangeAspect="1"/>
           </p:cNvPicPr>
@@ -8737,7 +8737,7 @@
         </p:blipFill>
         <p:spPr>
           <a:xfrm>
-            <a:off x="7199254" y="4858390"/>
+            <a:off x="7199254" y="3706246"/>
             <a:ext cx="286756" cy="286756"/>
           </a:xfrm>
           <a:prstGeom prst="rect">
@@ -8753,8 +8753,8 @@
         </p:nvSpPr>
         <p:spPr>
           <a:xfrm>
-            <a:off x="7799832" y="4672584"/>
-            <a:ext cx="3767328" cy="777240"/>
+            <a:off x="7799832" y="3520440"/>
+            <a:ext cx="3767328" cy="667512"/>
           </a:xfrm>
           <a:prstGeom prst="rect">
             <a:avLst/>
@@ -8778,7 +8778,7 @@
                   <a:schemeClr val="tx1"/>
                 </a:solidFill>
               </a:rPr>
-              <a:t>Favorittpoeng</a:t>
+              <a:t>Skjul geocacher</a:t>
             </a:r>
             <a:endParaRPr lang="en-US" sz="1700" dirty="0"/>
           </a:p>
@@ -8795,7 +8795,7 @@
                   <a:schemeClr val="accent4"/>
                 </a:solidFill>
               </a:rPr>
-              <a:t>♥ og antallet over cachene – av/på</a:t>
+              <a:t>Rent kart – klikk igjen for å vise dem</a:t>
             </a:r>
             <a:endParaRPr lang="en-US" sz="1700" dirty="0"/>
           </a:p>
@@ -8803,13 +8803,13 @@
       </p:sp>
       <p:sp>
         <p:nvSpPr>
-          <p:cNvPr id="13038" name="Ikon gear sirkel"/>
+          <p:cNvPr id="13038" name="Ikon heart sirkel"/>
           <p:cNvSpPr/>
           <p:nvPr/>
         </p:nvSpPr>
         <p:spPr>
           <a:xfrm>
-            <a:off x="7086600" y="5568696"/>
+            <a:off x="7086600" y="4306824"/>
             <a:ext cx="512064" cy="512064"/>
           </a:xfrm>
           <a:prstGeom prst="ellipse">
@@ -8823,7 +8823,7 @@
       </p:sp>
       <p:pic>
         <p:nvPicPr>
-          <p:cNvPr id="13039" name="Ikon gear" descr="gear">    </p:cNvPr>
+          <p:cNvPr id="13039" name="Ikon heart" descr="heart">    </p:cNvPr>
           <p:cNvPicPr>
             <a:picLocks noChangeAspect="1"/>
           </p:cNvPicPr>
@@ -8837,7 +8837,7 @@
         </p:blipFill>
         <p:spPr>
           <a:xfrm>
-            <a:off x="7199254" y="5681350"/>
+            <a:off x="7199254" y="4419478"/>
             <a:ext cx="286756" cy="286756"/>
           </a:xfrm>
           <a:prstGeom prst="rect">
@@ -8853,8 +8853,8 @@
         </p:nvSpPr>
         <p:spPr>
           <a:xfrm>
-            <a:off x="7799832" y="5495544"/>
-            <a:ext cx="3767328" cy="777240"/>
+            <a:off x="7799832" y="4233672"/>
+            <a:ext cx="3767328" cy="667512"/>
           </a:xfrm>
           <a:prstGeom prst="rect">
             <a:avLst/>
@@ -8878,7 +8878,7 @@
                   <a:schemeClr val="tx1"/>
                 </a:solidFill>
               </a:rPr>
-              <a:t>Innstillinger</a:t>
+              <a:t>Favorittpoeng</a:t>
             </a:r>
             <a:endParaRPr lang="en-US" sz="1700" dirty="0"/>
           </a:p>
@@ -8895,6 +8895,106 @@
                   <a:schemeClr val="accent4"/>
                 </a:solidFill>
               </a:rPr>
+              <a:t>♥ og antallet over cachene – av/på</a:t>
+            </a:r>
+            <a:endParaRPr lang="en-US" sz="1700" dirty="0"/>
+          </a:p>
+        </p:txBody>
+      </p:sp>
+      <p:sp>
+        <p:nvSpPr>
+          <p:cNvPr id="13041" name="Ikon gear sirkel"/>
+          <p:cNvSpPr/>
+          <p:nvPr/>
+        </p:nvSpPr>
+        <p:spPr>
+          <a:xfrm>
+            <a:off x="7086600" y="5020056"/>
+            <a:ext cx="512064" cy="512064"/>
+          </a:xfrm>
+          <a:prstGeom prst="ellipse">
+            <a:avLst/>
+          </a:prstGeom>
+          <a:solidFill>
+            <a:schemeClr val="accent1"/>
+          </a:solidFill>
+          <a:ln/>
+        </p:spPr>
+      </p:sp>
+      <p:pic>
+        <p:nvPicPr>
+          <p:cNvPr id="13042" name="Ikon gear" descr="gear">    </p:cNvPr>
+          <p:cNvPicPr>
+            <a:picLocks noChangeAspect="1"/>
+          </p:cNvPicPr>
+          <p:nvPr/>
+        </p:nvPicPr>
+        <p:blipFill>
+          <a:blip r:embed="rId14"/>
+          <a:stretch>
+            <a:fillRect/>
+          </a:stretch>
+        </p:blipFill>
+        <p:spPr>
+          <a:xfrm>
+            <a:off x="7199254" y="5132710"/>
+            <a:ext cx="286756" cy="286756"/>
+          </a:xfrm>
+          <a:prstGeom prst="rect">
+            <a:avLst/>
+          </a:prstGeom>
+        </p:spPr>
+      </p:pic>
+      <p:sp>
+        <p:nvSpPr>
+          <p:cNvPr id="13043" name="Text 27"/>
+          <p:cNvSpPr txBox="1"/>
+          <p:nvPr/>
+        </p:nvSpPr>
+        <p:spPr>
+          <a:xfrm>
+            <a:off x="7799832" y="4946904"/>
+            <a:ext cx="3767328" cy="667512"/>
+          </a:xfrm>
+          <a:prstGeom prst="rect">
+            <a:avLst/>
+          </a:prstGeom>
+          <a:noFill/>
+          <a:ln/>
+        </p:spPr>
+        <p:txBody>
+          <a:bodyPr wrap="square" lIns="0" tIns="0" rIns="0" bIns="0" rtlCol="0" anchor="t"/>
+          <a:lstStyle/>
+          <a:p>
+            <a:pPr indent="0" marL="0">
+              <a:spcAft>
+                <a:spcPts val="200"/>
+              </a:spcAft>
+              <a:buNone/>
+            </a:pPr>
+            <a:r>
+              <a:rPr lang="en-US" sz="1700" b="1" dirty="0">
+                <a:solidFill>
+                  <a:schemeClr val="tx1"/>
+                </a:solidFill>
+              </a:rPr>
+              <a:t>Innstillinger</a:t>
+            </a:r>
+            <a:endParaRPr lang="en-US" sz="1700" dirty="0"/>
+          </a:p>
+          <a:p>
+            <a:pPr indent="0" marL="0">
+              <a:spcAft>
+                <a:spcPts val="200"/>
+              </a:spcAft>
+              <a:buNone/>
+            </a:pPr>
+            <a:r>
+              <a:rPr lang="en-US" sz="1400" dirty="0">
+                <a:solidFill>
+                  <a:schemeClr val="accent4"/>
+                </a:solidFill>
+              </a:rPr>
               <a:t>Plassering, språk og nettstedets knapper</a:t>
             </a:r>
             <a:endParaRPr lang="en-US" sz="1700" dirty="0"/>
@@ -8903,7 +9003,7 @@
       </p:sp>
       <p:sp>
         <p:nvSpPr>
-          <p:cNvPr id="13041" name="Slide Number Placeholder 0"/>
+          <p:cNvPr id="13044" name="Slide Number Placeholder 0"/>
           <p:cNvSpPr>
             <a:spLocks noGrp="1"/>
           </p:cNvSpPr>
@@ -9047,8 +9147,8 @@
         </p:blipFill>
         <p:spPr>
           <a:xfrm>
-            <a:off x="8557751" y="1527048"/>
-            <a:ext cx="2147248" cy="4581144"/>
+            <a:off x="8583966" y="1527048"/>
+            <a:ext cx="2094818" cy="4581144"/>
           </a:xfrm>
           <a:prstGeom prst="rect">
             <a:avLst/>

</xml_diff>

<commit_message>
Documentation and homepage for 1.43.4 (FTF)
</commit_message>
<xml_diff>
--- a/docs/Geocaching-Map-Custom-Tile-Layers-Presentasjon.pptx
+++ b/docs/Geocaching-Map-Custom-Tile-Layers-Presentasjon.pptx
@@ -121,13 +121,13 @@
   <p:extLst>
     <p:ext uri="{521415D9-36F7-43E2-AB2F-B90AF26B5E84}">
       <p14:sectionLst xmlns:p14="http://schemas.microsoft.com/office/powerpoint/2010/main">
-        <p14:section name="Innledning" id="{8a699bff-e02a-219f-1bb2-d0929e28021a}">
+        <p14:section name="Innledning" id="{716c2bfb-6674-b90b-9ca2-594d79c18eee}">
           <p14:sldIdLst>
             <p14:sldId id="256"/>
             <p14:sldId id="257"/>
           </p14:sldIdLst>
         </p14:section>
-        <p14:section name="Funksjoner" id="{cbef5b9a-ad0b-c82f-4a40-645a2893c4f9}">
+        <p14:section name="Funksjoner" id="{e00297f4-95ab-8d89-b8ff-11cbea55be1f}">
           <p14:sldIdLst>
             <p14:sldId id="258"/>
             <p14:sldId id="259"/>
@@ -140,14 +140,14 @@
             <p14:sldId id="266"/>
           </p14:sldIdLst>
         </p14:section>
-        <p14:section name="Teknikk" id="{1677caf1-c50f-6121-4915-d32a830833f8}">
+        <p14:section name="Teknikk" id="{be1b69d7-ae20-d96d-5384-2c7434d8e6f8}">
           <p14:sldIdLst>
             <p14:sldId id="267"/>
             <p14:sldId id="268"/>
             <p14:sldId id="269"/>
           </p14:sldIdLst>
         </p14:section>
-        <p14:section name="Avslutning" id="{6b80d537-c68b-7710-6ffa-de399115a460}">
+        <p14:section name="Avslutning" id="{0500e12b-b775-41d0-c32d-a6ebe51797b8}">
           <p14:sldIdLst>
             <p14:sldId id="270"/>
           </p14:sldIdLst>
@@ -2063,7 +2063,7 @@
                   <a:schemeClr val="accent4"/>
                 </a:solidFill>
               </a:rPr>
-              <a:t>Geocaching Map – Custom Tile Layers · v1.42.1</a:t>
+              <a:t>Geocaching Map – Custom Tile Layers · v1.43.4</a:t>
             </a:r>
             <a:endParaRPr lang="en-US" sz="1000" dirty="0"/>
           </a:p>
@@ -2583,7 +2583,7 @@
                   <a:schemeClr val="accent5"/>
                 </a:solidFill>
               </a:rPr>
-              <a:t>Brukerskript · versjon 1.42.1 · norsk og engelsk</a:t>
+              <a:t>Brukerskript · versjon 1.43.4 · norsk og engelsk</a:t>
             </a:r>
             <a:endParaRPr lang="en-US" sz="1400" dirty="0"/>
           </a:p>

</xml_diff>

<commit_message>
Documentation and homepage for 1.44.0
</commit_message>
<xml_diff>
--- a/docs/Geocaching-Map-Custom-Tile-Layers-Presentasjon.pptx
+++ b/docs/Geocaching-Map-Custom-Tile-Layers-Presentasjon.pptx
@@ -121,13 +121,13 @@
   <p:extLst>
     <p:ext uri="{521415D9-36F7-43E2-AB2F-B90AF26B5E84}">
       <p14:sectionLst xmlns:p14="http://schemas.microsoft.com/office/powerpoint/2010/main">
-        <p14:section name="Innledning" id="{716c2bfb-6674-b90b-9ca2-594d79c18eee}">
+        <p14:section name="Innledning" id="{61806474-cef9-6fb0-0218-d6708a54d628}">
           <p14:sldIdLst>
             <p14:sldId id="256"/>
             <p14:sldId id="257"/>
           </p14:sldIdLst>
         </p14:section>
-        <p14:section name="Funksjoner" id="{e00297f4-95ab-8d89-b8ff-11cbea55be1f}">
+        <p14:section name="Funksjoner" id="{2b8f6f16-d3b6-8041-75ea-590a6e1224ee}">
           <p14:sldIdLst>
             <p14:sldId id="258"/>
             <p14:sldId id="259"/>
@@ -140,14 +140,14 @@
             <p14:sldId id="266"/>
           </p14:sldIdLst>
         </p14:section>
-        <p14:section name="Teknikk" id="{be1b69d7-ae20-d96d-5384-2c7434d8e6f8}">
+        <p14:section name="Teknikk" id="{01c875bd-ba8f-b4e8-fd29-fbe1ab8a90fc}">
           <p14:sldIdLst>
             <p14:sldId id="267"/>
             <p14:sldId id="268"/>
             <p14:sldId id="269"/>
           </p14:sldIdLst>
         </p14:section>
-        <p14:section name="Avslutning" id="{0500e12b-b775-41d0-c32d-a6ebe51797b8}">
+        <p14:section name="Avslutning" id="{d4aa99d0-3db2-5924-0d0e-9c32cb03cf4f}">
           <p14:sldIdLst>
             <p14:sldId id="270"/>
           </p14:sldIdLst>
@@ -2063,7 +2063,7 @@
                   <a:schemeClr val="accent4"/>
                 </a:solidFill>
               </a:rPr>
-              <a:t>Geocaching Map – Custom Tile Layers · v1.43.4</a:t>
+              <a:t>Geocaching Map – Custom Tile Layers · v1.44.0</a:t>
             </a:r>
             <a:endParaRPr lang="en-US" sz="1000" dirty="0"/>
           </a:p>
@@ -2583,7 +2583,7 @@
                   <a:schemeClr val="accent5"/>
                 </a:solidFill>
               </a:rPr>
-              <a:t>Brukerskript · versjon 1.43.4 · norsk og engelsk</a:t>
+              <a:t>Brukerskript · versjon 1.44.0 · norsk og engelsk</a:t>
             </a:r>
             <a:endParaRPr lang="en-US" sz="1400" dirty="0"/>
           </a:p>

</xml_diff>

<commit_message>
Documentation and homepage for 1.45.3
</commit_message>
<xml_diff>
--- a/docs/Geocaching-Map-Custom-Tile-Layers-Presentasjon.pptx
+++ b/docs/Geocaching-Map-Custom-Tile-Layers-Presentasjon.pptx
@@ -121,13 +121,13 @@
   <p:extLst>
     <p:ext uri="{521415D9-36F7-43E2-AB2F-B90AF26B5E84}">
       <p14:sectionLst xmlns:p14="http://schemas.microsoft.com/office/powerpoint/2010/main">
-        <p14:section name="Innledning" id="{61806474-cef9-6fb0-0218-d6708a54d628}">
+        <p14:section name="Innledning" id="{e2a1229a-a990-2527-4836-3676fec1fbe7}">
           <p14:sldIdLst>
             <p14:sldId id="256"/>
             <p14:sldId id="257"/>
           </p14:sldIdLst>
         </p14:section>
-        <p14:section name="Funksjoner" id="{2b8f6f16-d3b6-8041-75ea-590a6e1224ee}">
+        <p14:section name="Funksjoner" id="{7315a261-52ba-f65a-8a50-3de361b61491}">
           <p14:sldIdLst>
             <p14:sldId id="258"/>
             <p14:sldId id="259"/>
@@ -140,14 +140,14 @@
             <p14:sldId id="266"/>
           </p14:sldIdLst>
         </p14:section>
-        <p14:section name="Teknikk" id="{01c875bd-ba8f-b4e8-fd29-fbe1ab8a90fc}">
+        <p14:section name="Teknikk" id="{014fde8c-c9f3-9abd-b0f4-8f3e615bf6fa}">
           <p14:sldIdLst>
             <p14:sldId id="267"/>
             <p14:sldId id="268"/>
             <p14:sldId id="269"/>
           </p14:sldIdLst>
         </p14:section>
-        <p14:section name="Avslutning" id="{d4aa99d0-3db2-5924-0d0e-9c32cb03cf4f}">
+        <p14:section name="Avslutning" id="{b5edb349-189a-357d-7eb0-ae0842411ce7}">
           <p14:sldIdLst>
             <p14:sldId id="270"/>
           </p14:sldIdLst>
@@ -2063,7 +2063,7 @@
                   <a:schemeClr val="accent4"/>
                 </a:solidFill>
               </a:rPr>
-              <a:t>Geocaching Map – Custom Tile Layers · v1.44.0</a:t>
+              <a:t>Geocaching Map – Custom Tile Layers · v1.45.3</a:t>
             </a:r>
             <a:endParaRPr lang="en-US" sz="1000" dirty="0"/>
           </a:p>
@@ -2583,7 +2583,7 @@
                   <a:schemeClr val="accent5"/>
                 </a:solidFill>
               </a:rPr>
-              <a:t>Brukerskript · versjon 1.44.0 · norsk og engelsk</a:t>
+              <a:t>Brukerskript · versjon 1.45.3 · norsk og engelsk</a:t>
             </a:r>
             <a:endParaRPr lang="en-US" sz="1400" dirty="0"/>
           </a:p>

</xml_diff>

<commit_message>
Documentation and homepage for 1.47.0
</commit_message>
<xml_diff>
--- a/docs/Geocaching-Map-Custom-Tile-Layers-Presentasjon.pptx
+++ b/docs/Geocaching-Map-Custom-Tile-Layers-Presentasjon.pptx
@@ -121,13 +121,13 @@
   <p:extLst>
     <p:ext uri="{521415D9-36F7-43E2-AB2F-B90AF26B5E84}">
       <p14:sectionLst xmlns:p14="http://schemas.microsoft.com/office/powerpoint/2010/main">
-        <p14:section name="Innledning" id="{e2a1229a-a990-2527-4836-3676fec1fbe7}">
+        <p14:section name="Innledning" id="{b98ea0f0-c26a-d69e-c1e9-b3733e6e821a}">
           <p14:sldIdLst>
             <p14:sldId id="256"/>
             <p14:sldId id="257"/>
           </p14:sldIdLst>
         </p14:section>
-        <p14:section name="Funksjoner" id="{7315a261-52ba-f65a-8a50-3de361b61491}">
+        <p14:section name="Funksjoner" id="{ad012490-bcee-3bc5-4436-11d5a87f1214}">
           <p14:sldIdLst>
             <p14:sldId id="258"/>
             <p14:sldId id="259"/>
@@ -140,14 +140,14 @@
             <p14:sldId id="266"/>
           </p14:sldIdLst>
         </p14:section>
-        <p14:section name="Teknikk" id="{014fde8c-c9f3-9abd-b0f4-8f3e615bf6fa}">
+        <p14:section name="Teknikk" id="{c5376966-28ab-20e6-6035-eb47444e1c1f}">
           <p14:sldIdLst>
             <p14:sldId id="267"/>
             <p14:sldId id="268"/>
             <p14:sldId id="269"/>
           </p14:sldIdLst>
         </p14:section>
-        <p14:section name="Avslutning" id="{b5edb349-189a-357d-7eb0-ae0842411ce7}">
+        <p14:section name="Avslutning" id="{5097f304-1d8f-b8d5-c31d-462a0286bb32}">
           <p14:sldIdLst>
             <p14:sldId id="270"/>
           </p14:sldIdLst>
@@ -2063,7 +2063,7 @@
                   <a:schemeClr val="accent4"/>
                 </a:solidFill>
               </a:rPr>
-              <a:t>Geocaching Map – Custom Tile Layers · v1.45.3</a:t>
+              <a:t>Geocaching Map – Custom Tile Layers · v1.47.0</a:t>
             </a:r>
             <a:endParaRPr lang="en-US" sz="1000" dirty="0"/>
           </a:p>
@@ -2583,7 +2583,7 @@
                   <a:schemeClr val="accent5"/>
                 </a:solidFill>
               </a:rPr>
-              <a:t>Brukerskript · versjon 1.45.3 · norsk og engelsk</a:t>
+              <a:t>Brukerskript · versjon 1.47.0 · norsk og engelsk</a:t>
             </a:r>
             <a:endParaRPr lang="en-US" sz="1400" dirty="0"/>
           </a:p>

</xml_diff>

<commit_message>
Documentation and homepage for 1.50.2
</commit_message>
<xml_diff>
--- a/docs/Geocaching-Map-Custom-Tile-Layers-Presentasjon.pptx
+++ b/docs/Geocaching-Map-Custom-Tile-Layers-Presentasjon.pptx
@@ -122,13 +122,13 @@
   <p:extLst>
     <p:ext uri="{521415D9-36F7-43E2-AB2F-B90AF26B5E84}">
       <p14:sectionLst xmlns:p14="http://schemas.microsoft.com/office/powerpoint/2010/main">
-        <p14:section name="Innledning" id="{a5924676-3a88-0d70-55ff-b93cc8efc77a}">
+        <p14:section name="Innledning" id="{2e92f183-11ed-6aab-9b99-3266eb022818}">
           <p14:sldIdLst>
             <p14:sldId id="256"/>
             <p14:sldId id="257"/>
           </p14:sldIdLst>
         </p14:section>
-        <p14:section name="Funksjoner" id="{a09d9748-e601-ec2d-3570-349268443044}">
+        <p14:section name="Funksjoner" id="{b3207941-13f0-67e9-bfca-204c7b27678a}">
           <p14:sldIdLst>
             <p14:sldId id="258"/>
             <p14:sldId id="259"/>
@@ -142,14 +142,14 @@
             <p14:sldId id="267"/>
           </p14:sldIdLst>
         </p14:section>
-        <p14:section name="Teknikk" id="{982a2cdd-a62d-36fb-cc1c-4f8def81119f}">
+        <p14:section name="Teknikk" id="{39a5630b-3ebb-b7c3-fcd0-2f372f0d3de3}">
           <p14:sldIdLst>
             <p14:sldId id="268"/>
             <p14:sldId id="269"/>
             <p14:sldId id="270"/>
           </p14:sldIdLst>
         </p14:section>
-        <p14:section name="Avslutning" id="{0e19c752-6e78-fad7-b1ef-50a56f81216a}">
+        <p14:section name="Avslutning" id="{273ff730-7987-d31d-3495-08d8b9be8c5a}">
           <p14:sldIdLst>
             <p14:sldId id="271"/>
           </p14:sldIdLst>

</xml_diff>

<commit_message>
Docs 1.50.2: version in footers and deck, Greasy Fork texts
</commit_message>
<xml_diff>
--- a/docs/Geocaching-Map-Custom-Tile-Layers-Presentasjon.pptx
+++ b/docs/Geocaching-Map-Custom-Tile-Layers-Presentasjon.pptx
@@ -122,13 +122,13 @@
   <p:extLst>
     <p:ext uri="{521415D9-36F7-43E2-AB2F-B90AF26B5E84}">
       <p14:sectionLst xmlns:p14="http://schemas.microsoft.com/office/powerpoint/2010/main">
-        <p14:section name="Innledning" id="{2e92f183-11ed-6aab-9b99-3266eb022818}">
+        <p14:section name="Innledning" id="{bb18d423-6fd4-9c86-5a15-9e6b482442c6}">
           <p14:sldIdLst>
             <p14:sldId id="256"/>
             <p14:sldId id="257"/>
           </p14:sldIdLst>
         </p14:section>
-        <p14:section name="Funksjoner" id="{b3207941-13f0-67e9-bfca-204c7b27678a}">
+        <p14:section name="Funksjoner" id="{8eef0a39-63a1-b1ec-9954-3e75f5ccb53d}">
           <p14:sldIdLst>
             <p14:sldId id="258"/>
             <p14:sldId id="259"/>
@@ -142,14 +142,14 @@
             <p14:sldId id="267"/>
           </p14:sldIdLst>
         </p14:section>
-        <p14:section name="Teknikk" id="{39a5630b-3ebb-b7c3-fcd0-2f372f0d3de3}">
+        <p14:section name="Teknikk" id="{e0b8d13a-33d4-216c-5651-0dfe631a0a0b}">
           <p14:sldIdLst>
             <p14:sldId id="268"/>
             <p14:sldId id="269"/>
             <p14:sldId id="270"/>
           </p14:sldIdLst>
         </p14:section>
-        <p14:section name="Avslutning" id="{273ff730-7987-d31d-3495-08d8b9be8c5a}">
+        <p14:section name="Avslutning" id="{dd808892-1122-1d84-a8d2-1a25b676ff56}">
           <p14:sldIdLst>
             <p14:sldId id="271"/>
           </p14:sldIdLst>
@@ -2153,7 +2153,7 @@
                   <a:schemeClr val="accent4"/>
                 </a:solidFill>
               </a:rPr>
-              <a:t>Geocaching Map – Custom Tile Layers · v1.50.0</a:t>
+              <a:t>Geocaching Map – Custom Tile Layers · v1.50.2</a:t>
             </a:r>
             <a:endParaRPr lang="en-US" sz="1000" dirty="0"/>
           </a:p>
@@ -2673,7 +2673,7 @@
                   <a:schemeClr val="accent5"/>
                 </a:solidFill>
               </a:rPr>
-              <a:t>Brukerskript · versjon 1.50.0 · norsk og engelsk</a:t>
+              <a:t>Brukerskript · versjon 1.50.2 · norsk og engelsk</a:t>
             </a:r>
             <a:endParaRPr lang="en-US" sz="1400" dirty="0"/>
           </a:p>

</xml_diff>

<commit_message>
Documentation, Greasy Fork texts and homepage for 1.51.0
</commit_message>
<xml_diff>
--- a/docs/Geocaching-Map-Custom-Tile-Layers-Presentasjon.pptx
+++ b/docs/Geocaching-Map-Custom-Tile-Layers-Presentasjon.pptx
@@ -122,13 +122,13 @@
   <p:extLst>
     <p:ext uri="{521415D9-36F7-43E2-AB2F-B90AF26B5E84}">
       <p14:sectionLst xmlns:p14="http://schemas.microsoft.com/office/powerpoint/2010/main">
-        <p14:section name="Innledning" id="{bb18d423-6fd4-9c86-5a15-9e6b482442c6}">
+        <p14:section name="Innledning" id="{8172edfc-d2a0-349e-b602-c131f866fa5a}">
           <p14:sldIdLst>
             <p14:sldId id="256"/>
             <p14:sldId id="257"/>
           </p14:sldIdLst>
         </p14:section>
-        <p14:section name="Funksjoner" id="{8eef0a39-63a1-b1ec-9954-3e75f5ccb53d}">
+        <p14:section name="Funksjoner" id="{73d5cdbb-ea82-8ea5-5d1a-ce9f59f42087}">
           <p14:sldIdLst>
             <p14:sldId id="258"/>
             <p14:sldId id="259"/>
@@ -142,14 +142,14 @@
             <p14:sldId id="267"/>
           </p14:sldIdLst>
         </p14:section>
-        <p14:section name="Teknikk" id="{e0b8d13a-33d4-216c-5651-0dfe631a0a0b}">
+        <p14:section name="Teknikk" id="{3a83fa52-4186-c47b-0ac8-32467ddba295}">
           <p14:sldIdLst>
             <p14:sldId id="268"/>
             <p14:sldId id="269"/>
             <p14:sldId id="270"/>
           </p14:sldIdLst>
         </p14:section>
-        <p14:section name="Avslutning" id="{dd808892-1122-1d84-a8d2-1a25b676ff56}">
+        <p14:section name="Avslutning" id="{60a31e91-a676-955b-937d-408c0474ba13}">
           <p14:sldIdLst>
             <p14:sldId id="271"/>
           </p14:sldIdLst>
@@ -2153,7 +2153,7 @@
                   <a:schemeClr val="accent4"/>
                 </a:solidFill>
               </a:rPr>
-              <a:t>Geocaching Map – Custom Tile Layers · v1.50.2</a:t>
+              <a:t>Geocaching Map – Custom Tile Layers · v1.51.0</a:t>
             </a:r>
             <a:endParaRPr lang="en-US" sz="1000" dirty="0"/>
           </a:p>
@@ -2673,7 +2673,7 @@
                   <a:schemeClr val="accent5"/>
                 </a:solidFill>
               </a:rPr>
-              <a:t>Brukerskript · versjon 1.50.2 · norsk og engelsk</a:t>
+              <a:t>Brukerskript · versjon 1.51.0 · norsk og engelsk</a:t>
             </a:r>
             <a:endParaRPr lang="en-US" sz="1400" dirty="0"/>
           </a:p>
@@ -3096,7 +3096,7 @@
                   <a:schemeClr val="tx1"/>
                 </a:solidFill>
               </a:rPr>
-              <a:t>Rekkefølge og etapper</a:t>
+              <a:t>Rekkefølge og rundtur</a:t>
             </a:r>
             <a:endParaRPr lang="en-US" sz="1700" dirty="0"/>
           </a:p>
@@ -3113,7 +3113,7 @@
                   <a:schemeClr val="accent4"/>
                 </a:solidFill>
               </a:rPr>
-              <a:t>Flytt stopp, sorter etter nærmeste og se avstand og retning for hver etappe</a:t>
+              <a:t>Flytt stopp, sorter etter nærmeste, se hver etappe – og avslutt ved start</a:t>
             </a:r>
             <a:endParaRPr lang="en-US" sz="1700" dirty="0"/>
           </a:p>
@@ -3213,7 +3213,7 @@
                   <a:schemeClr val="accent4"/>
                 </a:solidFill>
               </a:rPr>
-              <a:t>Se hele ruten på kartet og i en tabell – last ned som GPX med Garmin-symboler</a:t>
+              <a:t>GPX med Garmin-symboler – eventuelt med fulle cachedata (papirløse cacher)</a:t>
             </a:r>
             <a:endParaRPr lang="en-US" sz="1700" dirty="0"/>
           </a:p>

</xml_diff>

<commit_message>
English presentation (PDF and PPTX) next to the Norwegian one
</commit_message>
<xml_diff>
--- a/docs/Geocaching-Map-Custom-Tile-Layers-Presentasjon.pptx
+++ b/docs/Geocaching-Map-Custom-Tile-Layers-Presentasjon.pptx
@@ -122,13 +122,13 @@
   <p:extLst>
     <p:ext uri="{521415D9-36F7-43E2-AB2F-B90AF26B5E84}">
       <p14:sectionLst xmlns:p14="http://schemas.microsoft.com/office/powerpoint/2010/main">
-        <p14:section name="Innledning" id="{8172edfc-d2a0-349e-b602-c131f866fa5a}">
+        <p14:section name="Innledning" id="{17b299b5-6ea9-31f7-e55f-d396b35258ec}">
           <p14:sldIdLst>
             <p14:sldId id="256"/>
             <p14:sldId id="257"/>
           </p14:sldIdLst>
         </p14:section>
-        <p14:section name="Funksjoner" id="{73d5cdbb-ea82-8ea5-5d1a-ce9f59f42087}">
+        <p14:section name="Funksjoner" id="{fa5e3aee-92e2-3ea9-4c28-30cee02b0046}">
           <p14:sldIdLst>
             <p14:sldId id="258"/>
             <p14:sldId id="259"/>
@@ -142,14 +142,14 @@
             <p14:sldId id="267"/>
           </p14:sldIdLst>
         </p14:section>
-        <p14:section name="Teknikk" id="{3a83fa52-4186-c47b-0ac8-32467ddba295}">
+        <p14:section name="Teknikk" id="{da83a7c1-664f-7b22-b16b-015c62b8d46c}">
           <p14:sldIdLst>
             <p14:sldId id="268"/>
             <p14:sldId id="269"/>
             <p14:sldId id="270"/>
           </p14:sldIdLst>
         </p14:section>
-        <p14:section name="Avslutning" id="{60a31e91-a676-955b-937d-408c0474ba13}">
+        <p14:section name="Avslutning" id="{ec24358b-905f-f65b-5e29-50144f20cc94}">
           <p14:sldIdLst>
             <p14:sldId id="271"/>
           </p14:sldIdLst>

</xml_diff>

<commit_message>
Presentations: Route button on the toolbar slide; docs at 1.51.9
</commit_message>
<xml_diff>
--- a/docs/Geocaching-Map-Custom-Tile-Layers-Presentasjon.pptx
+++ b/docs/Geocaching-Map-Custom-Tile-Layers-Presentasjon.pptx
@@ -122,13 +122,13 @@
   <p:extLst>
     <p:ext uri="{521415D9-36F7-43E2-AB2F-B90AF26B5E84}">
       <p14:sectionLst xmlns:p14="http://schemas.microsoft.com/office/powerpoint/2010/main">
-        <p14:section name="Innledning" id="{0df88a2c-a635-6252-68f4-73e9527f5163}">
+        <p14:section name="Innledning" id="{a063d472-58a3-3fc2-c0c0-428a547ed99c}">
           <p14:sldIdLst>
             <p14:sldId id="256"/>
             <p14:sldId id="257"/>
           </p14:sldIdLst>
         </p14:section>
-        <p14:section name="Funksjoner" id="{3e2f9805-4cee-b674-e259-cd3ad659f74d}">
+        <p14:section name="Funksjoner" id="{29fb335e-37ee-4225-3624-ff70d7fd4fb5}">
           <p14:sldIdLst>
             <p14:sldId id="258"/>
             <p14:sldId id="259"/>
@@ -142,14 +142,14 @@
             <p14:sldId id="267"/>
           </p14:sldIdLst>
         </p14:section>
-        <p14:section name="Teknikk" id="{e8db0675-c049-c607-cb28-dd3ae8f1dc8f}">
+        <p14:section name="Teknikk" id="{da43ab48-99aa-6505-abde-06e5e488389e}">
           <p14:sldIdLst>
             <p14:sldId id="268"/>
             <p14:sldId id="269"/>
             <p14:sldId id="270"/>
           </p14:sldIdLst>
         </p14:section>
-        <p14:section name="Avslutning" id="{8329e224-9124-077b-9931-6ff385905fd9}">
+        <p14:section name="Avslutning" id="{6557597e-57b9-18bc-836a-4cf9ed9b0136}">
           <p14:sldIdLst>
             <p14:sldId id="271"/>
           </p14:sldIdLst>
@@ -2153,7 +2153,7 @@
                   <a:schemeClr val="accent4"/>
                 </a:solidFill>
               </a:rPr>
-              <a:t>Geocaching Map – Custom Tile Layers · v1.51.0</a:t>
+              <a:t>Geocaching Map – Custom Tile Layers · v1.51.9</a:t>
             </a:r>
             <a:endParaRPr lang="en-US" sz="1000" dirty="0"/>
           </a:p>
@@ -2673,7 +2673,7 @@
                   <a:schemeClr val="accent5"/>
                 </a:solidFill>
               </a:rPr>
-              <a:t>Brukerskript · versjon 1.51.0 · norsk og engelsk</a:t>
+              <a:t>Brukerskript · versjon 1.51.9 · norsk og engelsk</a:t>
             </a:r>
             <a:endParaRPr lang="en-US" sz="1400" dirty="0"/>
           </a:p>
@@ -8647,7 +8647,7 @@
       </p:sp>
       <p:sp>
         <p:nvSpPr>
-          <p:cNvPr id="13014" name="Ikon circles sirkel"/>
+          <p:cNvPr id="13014" name="Ikon route sirkel"/>
           <p:cNvSpPr/>
           <p:nvPr/>
         </p:nvSpPr>
@@ -8667,7 +8667,7 @@
       </p:sp>
       <p:pic>
         <p:nvPicPr>
-          <p:cNvPr id="13015" name="Ikon circles" descr="circles">    </p:cNvPr>
+          <p:cNvPr id="13015" name="Ikon route" descr="route">    </p:cNvPr>
           <p:cNvPicPr>
             <a:picLocks noChangeAspect="1"/>
           </p:cNvPicPr>
@@ -8722,7 +8722,7 @@
                   <a:schemeClr val="tx1"/>
                 </a:solidFill>
               </a:rPr>
-              <a:t>161 m-sirkler</a:t>
+              <a:t>Rute</a:t>
             </a:r>
             <a:endParaRPr lang="en-US" sz="1700" dirty="0"/>
           </a:p>
@@ -8739,7 +8739,7 @@
                   <a:schemeClr val="accent4"/>
                 </a:solidFill>
               </a:rPr>
-              <a:t>Der noe er utplassert – fra zoom 15</a:t>
+              <a:t>Sett sammen en rute og last den ned som GPX</a:t>
             </a:r>
             <a:endParaRPr lang="en-US" sz="1700" dirty="0"/>
           </a:p>
@@ -8747,7 +8747,7 @@
       </p:sp>
       <p:sp>
         <p:nvSpPr>
-          <p:cNvPr id="13017" name="Ikon solved sirkel"/>
+          <p:cNvPr id="13017" name="Ikon circles sirkel"/>
           <p:cNvSpPr/>
           <p:nvPr/>
         </p:nvSpPr>
@@ -8767,7 +8767,7 @@
       </p:sp>
       <p:pic>
         <p:nvPicPr>
-          <p:cNvPr id="13018" name="Ikon solved" descr="solved">    </p:cNvPr>
+          <p:cNvPr id="13018" name="Ikon circles" descr="circles">    </p:cNvPr>
           <p:cNvPicPr>
             <a:picLocks noChangeAspect="1"/>
           </p:cNvPicPr>
@@ -8822,7 +8822,7 @@
                   <a:schemeClr val="tx1"/>
                 </a:solidFill>
               </a:rPr>
-              <a:t>Merker</a:t>
+              <a:t>161 m-sirkler</a:t>
             </a:r>
             <a:endParaRPr lang="en-US" sz="1700" dirty="0"/>
           </a:p>
@@ -8839,7 +8839,7 @@
                   <a:schemeClr val="accent4"/>
                 </a:solidFill>
               </a:rPr>
-              <a:t>Løste cacher, også uten sirkler</a:t>
+              <a:t>Der noe er utplassert – fra zoom 15</a:t>
             </a:r>
             <a:endParaRPr lang="en-US" sz="1700" dirty="0"/>
           </a:p>
@@ -8847,7 +8847,7 @@
       </p:sp>
       <p:sp>
         <p:nvSpPr>
-          <p:cNvPr id="13020" name="Ikon dt sirkel"/>
+          <p:cNvPr id="13020" name="Ikon solved sirkel"/>
           <p:cNvSpPr/>
           <p:nvPr/>
         </p:nvSpPr>
@@ -8867,7 +8867,7 @@
       </p:sp>
       <p:pic>
         <p:nvPicPr>
-          <p:cNvPr id="13021" name="Ikon dt" descr="dt">    </p:cNvPr>
+          <p:cNvPr id="13021" name="Ikon solved" descr="solved">    </p:cNvPr>
           <p:cNvPicPr>
             <a:picLocks noChangeAspect="1"/>
           </p:cNvPicPr>
@@ -8922,7 +8922,7 @@
                   <a:schemeClr val="tx1"/>
                 </a:solidFill>
               </a:rPr>
-              <a:t>D/T</a:t>
+              <a:t>Merker</a:t>
             </a:r>
             <a:endParaRPr lang="en-US" sz="1700" dirty="0"/>
           </a:p>
@@ -8939,7 +8939,7 @@
                   <a:schemeClr val="accent4"/>
                 </a:solidFill>
               </a:rPr>
-              <a:t>Vanskelighet/terreng under cachene – av/på</a:t>
+              <a:t>Løste cacher, også uten sirkler</a:t>
             </a:r>
             <a:endParaRPr lang="en-US" sz="1700" dirty="0"/>
           </a:p>
@@ -8947,7 +8947,7 @@
       </p:sp>
       <p:sp>
         <p:nvSpPr>
-          <p:cNvPr id="13023" name="Ikon locate sirkel"/>
+          <p:cNvPr id="13023" name="Ikon heart sirkel"/>
           <p:cNvSpPr/>
           <p:nvPr/>
         </p:nvSpPr>
@@ -8967,7 +8967,7 @@
       </p:sp>
       <p:pic>
         <p:nvPicPr>
-          <p:cNvPr id="13024" name="Ikon locate" descr="locate">    </p:cNvPr>
+          <p:cNvPr id="13024" name="Ikon heart" descr="heart">    </p:cNvPr>
           <p:cNvPicPr>
             <a:picLocks noChangeAspect="1"/>
           </p:cNvPicPr>
@@ -9022,7 +9022,7 @@
                   <a:schemeClr val="tx1"/>
                 </a:solidFill>
               </a:rPr>
-              <a:t>Min posisjon</a:t>
+              <a:t>Favorittpoeng</a:t>
             </a:r>
             <a:endParaRPr lang="en-US" sz="1700" dirty="0"/>
           </a:p>
@@ -9039,7 +9039,7 @@
                   <a:schemeClr val="accent4"/>
                 </a:solidFill>
               </a:rPr>
-              <a:t>Med sirkel for nøyaktighet</a:t>
+              <a:t>♥ og antallet over cachene – av/på</a:t>
             </a:r>
             <a:endParaRPr lang="en-US" sz="1700" dirty="0"/>
           </a:p>
@@ -9047,7 +9047,7 @@
       </p:sp>
       <p:sp>
         <p:nvSpPr>
-          <p:cNvPr id="13026" name="Ikon home sirkel"/>
+          <p:cNvPr id="13026" name="Ikon dt sirkel"/>
           <p:cNvSpPr/>
           <p:nvPr/>
         </p:nvSpPr>
@@ -9067,7 +9067,7 @@
       </p:sp>
       <p:pic>
         <p:nvPicPr>
-          <p:cNvPr id="13027" name="Ikon home" descr="home">    </p:cNvPr>
+          <p:cNvPr id="13027" name="Ikon dt" descr="dt">    </p:cNvPr>
           <p:cNvPicPr>
             <a:picLocks noChangeAspect="1"/>
           </p:cNvPicPr>
@@ -9122,7 +9122,7 @@
                   <a:schemeClr val="tx1"/>
                 </a:solidFill>
               </a:rPr>
-              <a:t>Hjem</a:t>
+              <a:t>D/T</a:t>
             </a:r>
             <a:endParaRPr lang="en-US" sz="1700" dirty="0"/>
           </a:p>
@@ -9139,7 +9139,7 @@
                   <a:schemeClr val="accent4"/>
                 </a:solidFill>
               </a:rPr>
-              <a:t>Høyreklikk for å endre adressen</a:t>
+              <a:t>Vanskelighet/terreng under cachene – av/på</a:t>
             </a:r>
             <a:endParaRPr lang="en-US" sz="1700" dirty="0"/>
           </a:p>
@@ -9147,7 +9147,7 @@
       </p:sp>
       <p:sp>
         <p:nvSpPr>
-          <p:cNvPr id="13029" name="Ikon expand sirkel"/>
+          <p:cNvPr id="13029" name="Ikon eyeoff sirkel"/>
           <p:cNvSpPr/>
           <p:nvPr/>
         </p:nvSpPr>
@@ -9167,7 +9167,7 @@
       </p:sp>
       <p:pic>
         <p:nvPicPr>
-          <p:cNvPr id="13030" name="Ikon expand" descr="expand">    </p:cNvPr>
+          <p:cNvPr id="13030" name="Ikon eyeoff" descr="eyeoff">    </p:cNvPr>
           <p:cNvPicPr>
             <a:picLocks noChangeAspect="1"/>
           </p:cNvPicPr>
@@ -9222,7 +9222,7 @@
                   <a:schemeClr val="tx1"/>
                 </a:solidFill>
               </a:rPr>
-              <a:t>Fullskjerm</a:t>
+              <a:t>Skjul geocacher</a:t>
             </a:r>
             <a:endParaRPr lang="en-US" sz="1700" dirty="0"/>
           </a:p>
@@ -9239,7 +9239,7 @@
                   <a:schemeClr val="accent4"/>
                 </a:solidFill>
               </a:rPr>
-              <a:t>Kartet fyller hele skjermen</a:t>
+              <a:t>Rent kart – klikk igjen for å vise dem</a:t>
             </a:r>
             <a:endParaRPr lang="en-US" sz="1700" dirty="0"/>
           </a:p>
@@ -9247,7 +9247,7 @@
       </p:sp>
       <p:sp>
         <p:nvSpPr>
-          <p:cNvPr id="13032" name="Ikon eraser sirkel"/>
+          <p:cNvPr id="13032" name="Ikon locate sirkel"/>
           <p:cNvSpPr/>
           <p:nvPr/>
         </p:nvSpPr>
@@ -9267,7 +9267,7 @@
       </p:sp>
       <p:pic>
         <p:nvPicPr>
-          <p:cNvPr id="13033" name="Ikon eraser" descr="eraser">    </p:cNvPr>
+          <p:cNvPr id="13033" name="Ikon locate" descr="locate">    </p:cNvPr>
           <p:cNvPicPr>
             <a:picLocks noChangeAspect="1"/>
           </p:cNvPicPr>
@@ -9322,7 +9322,7 @@
                   <a:schemeClr val="tx1"/>
                 </a:solidFill>
               </a:rPr>
-              <a:t>Fjern tegninger</a:t>
+              <a:t>Min posisjon</a:t>
             </a:r>
             <a:endParaRPr lang="en-US" sz="1700" dirty="0"/>
           </a:p>
@@ -9339,7 +9339,7 @@
                   <a:schemeClr val="accent4"/>
                 </a:solidFill>
               </a:rPr>
-              <a:t>Merker, målinger og sirkler</a:t>
+              <a:t>Med sirkel for nøyaktighet</a:t>
             </a:r>
             <a:endParaRPr lang="en-US" sz="1700" dirty="0"/>
           </a:p>
@@ -9347,7 +9347,7 @@
       </p:sp>
       <p:sp>
         <p:nvSpPr>
-          <p:cNvPr id="13035" name="Ikon eyeoff sirkel"/>
+          <p:cNvPr id="13035" name="Ikon home sirkel"/>
           <p:cNvSpPr/>
           <p:nvPr/>
         </p:nvSpPr>
@@ -9367,7 +9367,7 @@
       </p:sp>
       <p:pic>
         <p:nvPicPr>
-          <p:cNvPr id="13036" name="Ikon eyeoff" descr="eyeoff">    </p:cNvPr>
+          <p:cNvPr id="13036" name="Ikon home" descr="home">    </p:cNvPr>
           <p:cNvPicPr>
             <a:picLocks noChangeAspect="1"/>
           </p:cNvPicPr>
@@ -9422,7 +9422,7 @@
                   <a:schemeClr val="tx1"/>
                 </a:solidFill>
               </a:rPr>
-              <a:t>Skjul geocacher</a:t>
+              <a:t>Hjem</a:t>
             </a:r>
             <a:endParaRPr lang="en-US" sz="1700" dirty="0"/>
           </a:p>
@@ -9439,7 +9439,7 @@
                   <a:schemeClr val="accent4"/>
                 </a:solidFill>
               </a:rPr>
-              <a:t>Rent kart – klikk igjen for å vise dem</a:t>
+              <a:t>Høyreklikk for å endre adressen</a:t>
             </a:r>
             <a:endParaRPr lang="en-US" sz="1700" dirty="0"/>
           </a:p>
@@ -9447,7 +9447,7 @@
       </p:sp>
       <p:sp>
         <p:nvSpPr>
-          <p:cNvPr id="13038" name="Ikon heart sirkel"/>
+          <p:cNvPr id="13038" name="Ikon expand sirkel"/>
           <p:cNvSpPr/>
           <p:nvPr/>
         </p:nvSpPr>
@@ -9467,7 +9467,7 @@
       </p:sp>
       <p:pic>
         <p:nvPicPr>
-          <p:cNvPr id="13039" name="Ikon heart" descr="heart">    </p:cNvPr>
+          <p:cNvPr id="13039" name="Ikon expand" descr="expand">    </p:cNvPr>
           <p:cNvPicPr>
             <a:picLocks noChangeAspect="1"/>
           </p:cNvPicPr>
@@ -9522,7 +9522,7 @@
                   <a:schemeClr val="tx1"/>
                 </a:solidFill>
               </a:rPr>
-              <a:t>Favorittpoeng</a:t>
+              <a:t>Fullskjerm</a:t>
             </a:r>
             <a:endParaRPr lang="en-US" sz="1700" dirty="0"/>
           </a:p>
@@ -9539,7 +9539,7 @@
                   <a:schemeClr val="accent4"/>
                 </a:solidFill>
               </a:rPr>
-              <a:t>♥ og antallet over cachene – av/på</a:t>
+              <a:t>Kartet fyller hele skjermen</a:t>
             </a:r>
             <a:endParaRPr lang="en-US" sz="1700" dirty="0"/>
           </a:p>
@@ -9547,7 +9547,7 @@
       </p:sp>
       <p:sp>
         <p:nvSpPr>
-          <p:cNvPr id="13041" name="Ikon gear sirkel"/>
+          <p:cNvPr id="13041" name="Ikon eraser sirkel"/>
           <p:cNvSpPr/>
           <p:nvPr/>
         </p:nvSpPr>
@@ -9567,7 +9567,7 @@
       </p:sp>
       <p:pic>
         <p:nvPicPr>
-          <p:cNvPr id="13042" name="Ikon gear" descr="gear">    </p:cNvPr>
+          <p:cNvPr id="13042" name="Ikon eraser" descr="eraser">    </p:cNvPr>
           <p:cNvPicPr>
             <a:picLocks noChangeAspect="1"/>
           </p:cNvPicPr>
@@ -9622,7 +9622,7 @@
                   <a:schemeClr val="tx1"/>
                 </a:solidFill>
               </a:rPr>
-              <a:t>Innstillinger</a:t>
+              <a:t>Fjern tegninger</a:t>
             </a:r>
             <a:endParaRPr lang="en-US" sz="1700" dirty="0"/>
           </a:p>
@@ -9639,6 +9639,106 @@
                   <a:schemeClr val="accent4"/>
                 </a:solidFill>
               </a:rPr>
+              <a:t>Merker, målinger og sirkler</a:t>
+            </a:r>
+            <a:endParaRPr lang="en-US" sz="1700" dirty="0"/>
+          </a:p>
+        </p:txBody>
+      </p:sp>
+      <p:sp>
+        <p:nvSpPr>
+          <p:cNvPr id="13044" name="Ikon gear sirkel"/>
+          <p:cNvSpPr/>
+          <p:nvPr/>
+        </p:nvSpPr>
+        <p:spPr>
+          <a:xfrm>
+            <a:off x="7086600" y="5733288"/>
+            <a:ext cx="512064" cy="512064"/>
+          </a:xfrm>
+          <a:prstGeom prst="ellipse">
+            <a:avLst/>
+          </a:prstGeom>
+          <a:solidFill>
+            <a:schemeClr val="accent1"/>
+          </a:solidFill>
+          <a:ln/>
+        </p:spPr>
+      </p:sp>
+      <p:pic>
+        <p:nvPicPr>
+          <p:cNvPr id="13045" name="Ikon gear" descr="gear">    </p:cNvPr>
+          <p:cNvPicPr>
+            <a:picLocks noChangeAspect="1"/>
+          </p:cNvPicPr>
+          <p:nvPr/>
+        </p:nvPicPr>
+        <p:blipFill>
+          <a:blip r:embed="rId15"/>
+          <a:stretch>
+            <a:fillRect/>
+          </a:stretch>
+        </p:blipFill>
+        <p:spPr>
+          <a:xfrm>
+            <a:off x="7199254" y="5845942"/>
+            <a:ext cx="286756" cy="286756"/>
+          </a:xfrm>
+          <a:prstGeom prst="rect">
+            <a:avLst/>
+          </a:prstGeom>
+        </p:spPr>
+      </p:pic>
+      <p:sp>
+        <p:nvSpPr>
+          <p:cNvPr id="13046" name="Text 29"/>
+          <p:cNvSpPr txBox="1"/>
+          <p:nvPr/>
+        </p:nvSpPr>
+        <p:spPr>
+          <a:xfrm>
+            <a:off x="7799832" y="5660136"/>
+            <a:ext cx="3767328" cy="667512"/>
+          </a:xfrm>
+          <a:prstGeom prst="rect">
+            <a:avLst/>
+          </a:prstGeom>
+          <a:noFill/>
+          <a:ln/>
+        </p:spPr>
+        <p:txBody>
+          <a:bodyPr wrap="square" lIns="0" tIns="0" rIns="0" bIns="0" rtlCol="0" anchor="t"/>
+          <a:lstStyle/>
+          <a:p>
+            <a:pPr indent="0" marL="0">
+              <a:spcAft>
+                <a:spcPts val="200"/>
+              </a:spcAft>
+              <a:buNone/>
+            </a:pPr>
+            <a:r>
+              <a:rPr lang="en-US" sz="1700" b="1" dirty="0">
+                <a:solidFill>
+                  <a:schemeClr val="tx1"/>
+                </a:solidFill>
+              </a:rPr>
+              <a:t>Innstillinger</a:t>
+            </a:r>
+            <a:endParaRPr lang="en-US" sz="1700" dirty="0"/>
+          </a:p>
+          <a:p>
+            <a:pPr indent="0" marL="0">
+              <a:spcAft>
+                <a:spcPts val="200"/>
+              </a:spcAft>
+              <a:buNone/>
+            </a:pPr>
+            <a:r>
+              <a:rPr lang="en-US" sz="1400" dirty="0">
+                <a:solidFill>
+                  <a:schemeClr val="accent4"/>
+                </a:solidFill>
+              </a:rPr>
               <a:t>Plassering, språk og nettstedets knapper</a:t>
             </a:r>
             <a:endParaRPr lang="en-US" sz="1700" dirty="0"/>
@@ -9647,7 +9747,7 @@
       </p:sp>
       <p:sp>
         <p:nvSpPr>
-          <p:cNvPr id="13044" name="Slide Number Placeholder 0"/>
+          <p:cNvPr id="13047" name="Slide Number Placeholder 0"/>
           <p:cNvSpPr>
             <a:spLocks noGrp="1"/>
           </p:cNvSpPr>

</xml_diff>

<commit_message>
Docs: /map and /play/map instead of old and new map
</commit_message>
<xml_diff>
--- a/docs/Geocaching-Map-Custom-Tile-Layers-Presentasjon.pptx
+++ b/docs/Geocaching-Map-Custom-Tile-Layers-Presentasjon.pptx
@@ -123,13 +123,13 @@
   <p:extLst>
     <p:ext uri="{521415D9-36F7-43E2-AB2F-B90AF26B5E84}">
       <p14:sectionLst xmlns:p14="http://schemas.microsoft.com/office/powerpoint/2010/main">
-        <p14:section name="Innledning" id="{9f0d9170-f495-affd-6275-9c7137eac8cc}">
+        <p14:section name="Innledning" id="{a94511b9-f84a-a609-2193-9f261441b6e9}">
           <p14:sldIdLst>
             <p14:sldId id="256"/>
             <p14:sldId id="257"/>
           </p14:sldIdLst>
         </p14:section>
-        <p14:section name="Funksjoner" id="{2558ab7a-2606-8852-512d-25a9654f1490}">
+        <p14:section name="Funksjoner" id="{61cc43ce-fe19-7bd5-1c1a-b64f58ea2679}">
           <p14:sldIdLst>
             <p14:sldId id="258"/>
             <p14:sldId id="259"/>
@@ -144,14 +144,14 @@
             <p14:sldId id="268"/>
           </p14:sldIdLst>
         </p14:section>
-        <p14:section name="Teknikk" id="{2be404a8-cfcf-feae-a3e1-54f9df28b320}">
+        <p14:section name="Teknikk" id="{fa8dfe76-ed76-36a5-8ef4-b7ab91e1cb00}">
           <p14:sldIdLst>
             <p14:sldId id="269"/>
             <p14:sldId id="270"/>
             <p14:sldId id="271"/>
           </p14:sldIdLst>
         </p14:section>
-        <p14:section name="Avslutning" id="{09f9528f-5bf8-fad3-52da-f1685ae43be5}">
+        <p14:section name="Avslutning" id="{7a81dff4-bf10-ec15-a5ca-80db46c14c2d}">
           <p14:sldIdLst>
             <p14:sldId id="272"/>
           </p14:sldIdLst>
@@ -736,7 +736,7 @@
           <a:p>
             <a:r>
               <a:rPr lang="en-US" dirty="0"/>
-              <a:t>Cachelisten finnes på det gamle kartet (/map); det nye kartet har sin egen liste. Listen og rutevinduet står øverst til høyre eller venstre på kartet (Innstillinger), unna nettstedets sidepanel, og de to knappene bytter mellom dem.</a:t>
+              <a:t>Cachelisten finnes på /map; /play/map har sin egen liste. Listen og rutevinduet står øverst til høyre eller venstre på kartet (Innstillinger), unna nettstedets sidepanel, og de to knappene bytter mellom dem.</a:t>
             </a:r>
             <a:endParaRPr lang="en-US" dirty="0"/>
           </a:p>
@@ -912,7 +912,7 @@
           <a:p>
             <a:r>
               <a:rPr lang="en-US" dirty="0"/>
-              <a:t>161 m er minsteavstanden mellom cacher i retningslinjene. På det gamle kartet finner skriptet posisjonene fra et skjult rutenett nettstedet laster; på de nye kartene brukes de nøyaktige posisjonene.</a:t>
+              <a:t>161 m er minsteavstanden mellom cacher i retningslinjene. På /map finner skriptet posisjonene fra et skjult rutenett nettstedet laster; på /play/map brukes de nøyaktige posisjonene.</a:t>
             </a:r>
             <a:endParaRPr lang="en-US" dirty="0"/>
           </a:p>
@@ -1000,7 +1000,7 @@
           <a:p>
             <a:r>
               <a:rPr lang="en-US" dirty="0"/>
-              <a:t>Nettleseren tegner Leaflets kontroller øverst, deretter boblene, markørene og tegningene, og nederst kartflisene. Blant flisene sorterer skriptet etter z-indeks: nettstedets bakgrunn nederst, så ditt bakgrunnskart, overleggene og forhåndsvisningen, og øverst nettstedets øvrige fliser – på det gamle kartet er det cacheikonene. Nettstedets bakgrunn finnes fra nettstedets lagvelger, ellers som det laveste fliselaget. Dialogene ligger utenfor kartet, festet til siden, så sidepanelet ikke dekker dem.</a:t>
+              <a:t>Nettleseren tegner Leaflets kontroller øverst, deretter boblene, markørene og tegningene, og nederst kartflisene. Blant flisene sorterer skriptet etter z-indeks: nettstedets bakgrunn nederst, så ditt bakgrunnskart, overleggene og forhåndsvisningen, og øverst nettstedets øvrige fliser – på /map er det cacheikonene. Nettstedets bakgrunn finnes fra nettstedets lagvelger, ellers som det laveste fliselaget. Dialogene ligger utenfor kartet, festet til siden, så sidepanelet ikke dekker dem.</a:t>
             </a:r>
             <a:endParaRPr lang="en-US" dirty="0"/>
           </a:p>
@@ -9483,7 +9483,7 @@
                   <a:schemeClr val="accent4"/>
                 </a:solidFill>
               </a:rPr>
-              <a:t>En liste som følger kartet (gamle kartet)</a:t>
+              <a:t>En liste som følger kartet (/map)</a:t>
             </a:r>
             <a:endParaRPr lang="en-US" sz="1700" dirty="0"/>
           </a:p>
@@ -13870,7 +13870,7 @@
                   <a:schemeClr val="accent4"/>
                 </a:solidFill>
               </a:rPr>
-              <a:t>Nøyaktige koordinater fra geocaching.coms cachesøk – også på det gamle kartet. Bare før søket har svart, beregnes posisjonen fra ikonet (≈).</a:t>
+              <a:t>Nøyaktige koordinater fra geocaching.coms cachesøk – også på /map. Bare før søket har svart, beregnes posisjonen fra ikonet (≈).</a:t>
             </a:r>
             <a:endParaRPr lang="en-US" sz="1500" dirty="0"/>
           </a:p>

</xml_diff>

<commit_message>
1.54.19 – New setting: start with the site's side panel folded away. After the first time the map opens with the panel already folded – nothing is seen opening or closing, and the toolbar and scale bar appear in place. A toolbar on the left sits beside a folded panel's tab and stays centred vertically.
</commit_message>
<xml_diff>
--- a/docs/Geocaching-Map-Custom-Tile-Layers-Presentasjon.pptx
+++ b/docs/Geocaching-Map-Custom-Tile-Layers-Presentasjon.pptx
@@ -123,13 +123,13 @@
   <p:extLst>
     <p:ext uri="{521415D9-36F7-43E2-AB2F-B90AF26B5E84}">
       <p14:sectionLst xmlns:p14="http://schemas.microsoft.com/office/powerpoint/2010/main">
-        <p14:section name="Innledning" id="{2e185250-ec87-02a1-1578-54e8290563b0}">
+        <p14:section name="Innledning" id="{8d84b1b2-579a-dd3f-a692-d6e8fb5d9b26}">
           <p14:sldIdLst>
             <p14:sldId id="256"/>
             <p14:sldId id="257"/>
           </p14:sldIdLst>
         </p14:section>
-        <p14:section name="Funksjoner" id="{6a120085-e199-8d24-7208-7e9b4abdffd6}">
+        <p14:section name="Funksjoner" id="{c8c85b1b-18f5-b03a-42d1-6a7eecc5ee01}">
           <p14:sldIdLst>
             <p14:sldId id="258"/>
             <p14:sldId id="259"/>
@@ -144,14 +144,14 @@
             <p14:sldId id="268"/>
           </p14:sldIdLst>
         </p14:section>
-        <p14:section name="Teknikk" id="{f48159cb-9c54-e5fe-03a5-1ef16e323775}">
+        <p14:section name="Teknikk" id="{dee17361-4ac8-a9c5-2c28-99d354b178cc}">
           <p14:sldIdLst>
             <p14:sldId id="269"/>
             <p14:sldId id="270"/>
             <p14:sldId id="271"/>
           </p14:sldIdLst>
         </p14:section>
-        <p14:section name="Avslutning" id="{7f863aaf-d2df-4158-e4c3-4bd798b2d36c}">
+        <p14:section name="Avslutning" id="{694ebe2e-b3cc-6f3c-34e2-1a32f3eb3a3b}">
           <p14:sldIdLst>
             <p14:sldId id="272"/>
           </p14:sldIdLst>
@@ -2243,7 +2243,7 @@
                   <a:schemeClr val="accent4"/>
                 </a:solidFill>
               </a:rPr>
-              <a:t>Geocaching Map – Custom Tile Layers · v1.53.11</a:t>
+              <a:t>Geocaching Map – Custom Tile Layers · v1.54.19</a:t>
             </a:r>
             <a:endParaRPr lang="en-US" sz="1000" dirty="0"/>
           </a:p>
@@ -2763,7 +2763,7 @@
                   <a:schemeClr val="accent5"/>
                 </a:solidFill>
               </a:rPr>
-              <a:t>Brukerskript · versjon 1.53.11 · norsk og engelsk</a:t>
+              <a:t>Brukerskript · versjon 1.54.19 · norsk og engelsk</a:t>
             </a:r>
             <a:endParaRPr lang="en-US" sz="1400" dirty="0"/>
           </a:p>

</xml_diff>

<commit_message>
1.54.26 – Starting with the side panel folded away (to see as much map as possible) is now smooth on /map and /play/map: the panel, its arrow and the toolbar are in place from the first moment, without flicker.
</commit_message>
<xml_diff>
--- a/docs/Geocaching-Map-Custom-Tile-Layers-Presentasjon.pptx
+++ b/docs/Geocaching-Map-Custom-Tile-Layers-Presentasjon.pptx
@@ -123,13 +123,13 @@
   <p:extLst>
     <p:ext uri="{521415D9-36F7-43E2-AB2F-B90AF26B5E84}">
       <p14:sectionLst xmlns:p14="http://schemas.microsoft.com/office/powerpoint/2010/main">
-        <p14:section name="Innledning" id="{8d84b1b2-579a-dd3f-a692-d6e8fb5d9b26}">
+        <p14:section name="Innledning" id="{afe012cc-5125-aa5a-d26e-e4d33cdad08c}">
           <p14:sldIdLst>
             <p14:sldId id="256"/>
             <p14:sldId id="257"/>
           </p14:sldIdLst>
         </p14:section>
-        <p14:section name="Funksjoner" id="{c8c85b1b-18f5-b03a-42d1-6a7eecc5ee01}">
+        <p14:section name="Funksjoner" id="{f5410c82-7361-9d41-d802-bb06702bd659}">
           <p14:sldIdLst>
             <p14:sldId id="258"/>
             <p14:sldId id="259"/>
@@ -144,14 +144,14 @@
             <p14:sldId id="268"/>
           </p14:sldIdLst>
         </p14:section>
-        <p14:section name="Teknikk" id="{dee17361-4ac8-a9c5-2c28-99d354b178cc}">
+        <p14:section name="Teknikk" id="{e4a7748f-beec-26bd-6657-9da07441a77f}">
           <p14:sldIdLst>
             <p14:sldId id="269"/>
             <p14:sldId id="270"/>
             <p14:sldId id="271"/>
           </p14:sldIdLst>
         </p14:section>
-        <p14:section name="Avslutning" id="{694ebe2e-b3cc-6f3c-34e2-1a32f3eb3a3b}">
+        <p14:section name="Avslutning" id="{26d81afa-8866-12e2-8814-9a78c45fba6b}">
           <p14:sldIdLst>
             <p14:sldId id="272"/>
           </p14:sldIdLst>
@@ -2243,7 +2243,7 @@
                   <a:schemeClr val="accent4"/>
                 </a:solidFill>
               </a:rPr>
-              <a:t>Geocaching Map – Custom Tile Layers · v1.54.19</a:t>
+              <a:t>Geocaching Map – Custom Tile Layers · v1.54.26</a:t>
             </a:r>
             <a:endParaRPr lang="en-US" sz="1000" dirty="0"/>
           </a:p>
@@ -2763,7 +2763,7 @@
                   <a:schemeClr val="accent5"/>
                 </a:solidFill>
               </a:rPr>
-              <a:t>Brukerskript · versjon 1.54.19 · norsk og engelsk</a:t>
+              <a:t>Brukerskript · versjon 1.54.26 · norsk og engelsk</a:t>
             </a:r>
             <a:endParaRPr lang="en-US" sz="1400" dirty="0"/>
           </a:p>

</xml_diff>

<commit_message>
1.54.47 – Solved caches you haven't found get a small type icon at the bottom right of the site's “solved” icon (can be turned off in Settings); guides and presentations updated
</commit_message>
<xml_diff>
--- a/docs/Geocaching-Map-Custom-Tile-Layers-Presentasjon.pptx
+++ b/docs/Geocaching-Map-Custom-Tile-Layers-Presentasjon.pptx
@@ -123,13 +123,13 @@
   <p:extLst>
     <p:ext uri="{521415D9-36F7-43E2-AB2F-B90AF26B5E84}">
       <p14:sectionLst xmlns:p14="http://schemas.microsoft.com/office/powerpoint/2010/main">
-        <p14:section name="Innledning" id="{afe012cc-5125-aa5a-d26e-e4d33cdad08c}">
+        <p14:section name="Innledning" id="{a41f9666-53b0-45b7-9a1f-1330a12729f7}">
           <p14:sldIdLst>
             <p14:sldId id="256"/>
             <p14:sldId id="257"/>
           </p14:sldIdLst>
         </p14:section>
-        <p14:section name="Funksjoner" id="{f5410c82-7361-9d41-d802-bb06702bd659}">
+        <p14:section name="Funksjoner" id="{dddb27b0-7981-eec3-2c08-2df4894e6684}">
           <p14:sldIdLst>
             <p14:sldId id="258"/>
             <p14:sldId id="259"/>
@@ -144,14 +144,14 @@
             <p14:sldId id="268"/>
           </p14:sldIdLst>
         </p14:section>
-        <p14:section name="Teknikk" id="{e4a7748f-beec-26bd-6657-9da07441a77f}">
+        <p14:section name="Teknikk" id="{80f792c7-b381-1e5d-4cbc-b7437e7ff8c6}">
           <p14:sldIdLst>
             <p14:sldId id="269"/>
             <p14:sldId id="270"/>
             <p14:sldId id="271"/>
           </p14:sldIdLst>
         </p14:section>
-        <p14:section name="Avslutning" id="{26d81afa-8866-12e2-8814-9a78c45fba6b}">
+        <p14:section name="Avslutning" id="{c0e61634-44fa-6df7-32b7-70129fbb8479}">
           <p14:sldIdLst>
             <p14:sldId id="272"/>
           </p14:sldIdLst>
@@ -824,7 +824,7 @@
           <a:p>
             <a:r>
               <a:rPr lang="en-US" dirty="0"/>
-              <a:t>Sirklene vises fra zoomnivå 15. Cachetypene, de nøyaktige koordinatene og dine løste koordinater kommer fra geocaching.coms eget cachesøk. Fysiske steg leses fra listen over tilleggsveipunkter på cachesiden – bare de eieren har gjort synlige. Blått merke med spørsmålstegn og grønn hake: en løst cache du har funnet. Liten blå prikk: fysisk steg. Liten grønn prikk: endelig plassering. Dine egne cacher, som cachesøket utelater, leses fra cachesidene; der beholdes nettstedets ikon og boble, men teksten ved musepekeren blir «Endelig plassering».</a:t>
+              <a:t>Sirklene vises fra zoomnivå 15. Cachetypene, de nøyaktige koordinatene og dine løste koordinater kommer fra geocaching.coms eget cachesøk. Fysiske steg leses fra listen over tilleggsveipunkter på cachesiden – bare de eieren har gjort synlige. Blått merke med spørsmålstegn og grønn hake: en løst cache du har funnet. Liten blå prikk: fysisk steg. Liten grønn prikk: endelig plassering. Dine egne cacher, som cachesøket utelater, leses fra cachesidene; der beholdes nettstedets ikon og boble, men teksten ved musepekeren blir «Endelig plassering». Løste cacher du ikke har funnet får et lite typeikon nede til høyre på nettstedets «løst»-ikon, siden det ikke viser cachetypen. Kartlagpanelet, søket og innstillingene åpnes der du sist dro dem.</a:t>
             </a:r>
             <a:endParaRPr lang="en-US" dirty="0"/>
           </a:p>
@@ -2243,7 +2243,7 @@
                   <a:schemeClr val="accent4"/>
                 </a:solidFill>
               </a:rPr>
-              <a:t>Geocaching Map – Custom Tile Layers · v1.54.26</a:t>
+              <a:t>Geocaching Map – Custom Tile Layers · v1.54.47</a:t>
             </a:r>
             <a:endParaRPr lang="en-US" sz="1000" dirty="0"/>
           </a:p>
@@ -2763,7 +2763,7 @@
                   <a:schemeClr val="accent5"/>
                 </a:solidFill>
               </a:rPr>
-              <a:t>Brukerskript · versjon 1.54.26 · norsk og engelsk</a:t>
+              <a:t>Brukerskript · versjon 1.54.47 · norsk og engelsk</a:t>
             </a:r>
             <a:endParaRPr lang="en-US" sz="1400" dirty="0"/>
           </a:p>
@@ -2785,8 +2785,8 @@
         </p:blipFill>
         <p:spPr>
           <a:xfrm>
-            <a:off x="8742823" y="548640"/>
-            <a:ext cx="2534472" cy="5760720"/>
+            <a:off x="8763083" y="548640"/>
+            <a:ext cx="2514213" cy="5760720"/>
           </a:xfrm>
           <a:prstGeom prst="rect">
             <a:avLst/>
@@ -4165,7 +4165,7 @@
                   <a:schemeClr val="accent4"/>
                 </a:solidFill>
               </a:rPr>
-              <a:t>På dine korrigerte koordinater – også når ikonet er flyttet tilbake etter funn</a:t>
+              <a:t>På dine korrigerte koordinater – også når ikonet er flyttet tilbake etter funn; et lite typeikon viser cachetypen</a:t>
             </a:r>
             <a:endParaRPr lang="en-US" sz="1700" dirty="0"/>
           </a:p>
@@ -10635,8 +10635,8 @@
         </p:blipFill>
         <p:spPr>
           <a:xfrm>
-            <a:off x="8623621" y="1527048"/>
-            <a:ext cx="2015509" cy="4581144"/>
+            <a:off x="8631676" y="1527048"/>
+            <a:ext cx="1999398" cy="4581144"/>
           </a:xfrm>
           <a:prstGeom prst="rect">
             <a:avLst/>

</xml_diff>

<commit_message>
1.54.50 – Optional small type icon (Settings, off by default) on all solved caches, found or not; the found tick moved to the bottom left; guides and presentations updated
</commit_message>
<xml_diff>
--- a/docs/Geocaching-Map-Custom-Tile-Layers-Presentasjon.pptx
+++ b/docs/Geocaching-Map-Custom-Tile-Layers-Presentasjon.pptx
@@ -123,13 +123,13 @@
   <p:extLst>
     <p:ext uri="{521415D9-36F7-43E2-AB2F-B90AF26B5E84}">
       <p14:sectionLst xmlns:p14="http://schemas.microsoft.com/office/powerpoint/2010/main">
-        <p14:section name="Innledning" id="{a41f9666-53b0-45b7-9a1f-1330a12729f7}">
+        <p14:section name="Innledning" id="{998e2ce4-f795-310a-0ea3-60e9b422603c}">
           <p14:sldIdLst>
             <p14:sldId id="256"/>
             <p14:sldId id="257"/>
           </p14:sldIdLst>
         </p14:section>
-        <p14:section name="Funksjoner" id="{dddb27b0-7981-eec3-2c08-2df4894e6684}">
+        <p14:section name="Funksjoner" id="{5b88f283-1f68-0961-5b54-cf471a5e2568}">
           <p14:sldIdLst>
             <p14:sldId id="258"/>
             <p14:sldId id="259"/>
@@ -144,14 +144,14 @@
             <p14:sldId id="268"/>
           </p14:sldIdLst>
         </p14:section>
-        <p14:section name="Teknikk" id="{80f792c7-b381-1e5d-4cbc-b7437e7ff8c6}">
+        <p14:section name="Teknikk" id="{46e4f3be-e0b2-d555-7dd8-46582cf16c9d}">
           <p14:sldIdLst>
             <p14:sldId id="269"/>
             <p14:sldId id="270"/>
             <p14:sldId id="271"/>
           </p14:sldIdLst>
         </p14:section>
-        <p14:section name="Avslutning" id="{c0e61634-44fa-6df7-32b7-70129fbb8479}">
+        <p14:section name="Avslutning" id="{5abb8aaa-4d3a-cc56-a622-bd4266de66a6}">
           <p14:sldIdLst>
             <p14:sldId id="272"/>
           </p14:sldIdLst>
@@ -824,7 +824,7 @@
           <a:p>
             <a:r>
               <a:rPr lang="en-US" dirty="0"/>
-              <a:t>Sirklene vises fra zoomnivå 15. Cachetypene, de nøyaktige koordinatene og dine løste koordinater kommer fra geocaching.coms eget cachesøk. Fysiske steg leses fra listen over tilleggsveipunkter på cachesiden – bare de eieren har gjort synlige. Blått merke med spørsmålstegn og grønn hake: en løst cache du har funnet. Liten blå prikk: fysisk steg. Liten grønn prikk: endelig plassering. Dine egne cacher, som cachesøket utelater, leses fra cachesidene; der beholdes nettstedets ikon og boble, men teksten ved musepekeren blir «Endelig plassering». Løste cacher du ikke har funnet får et lite typeikon nede til høyre på nettstedets «løst»-ikon, siden det ikke viser cachetypen. Kartlagpanelet, søket og innstillingene åpnes der du sist dro dem.</a:t>
+              <a:t>Sirklene vises fra zoomnivå 15. Cachetypene, de nøyaktige koordinatene og dine løste koordinater kommer fra geocaching.coms eget cachesøk. Fysiske steg leses fra listen over tilleggsveipunkter på cachesiden – bare de eieren har gjort synlige. Blått merke med spørsmålstegn og grønn hake: en løst cache du har funnet. Liten blå prikk: fysisk steg. Liten grønn prikk: endelig plassering. Dine egne cacher, som cachesøket utelater, leses fra cachesidene; der beholdes nettstedets ikon og boble, men teksten ved musepekeren blir «Endelig plassering». Et lite typeikon kan vises nede til høyre på løste cacher – på nettstedets «løst»-ikon og på våre merker – siden «løst»-ikonet ikke viser cachetypen (Innstillinger, av som standard). Kartlagpanelet, søket og innstillingene åpnes der du sist dro dem.</a:t>
             </a:r>
             <a:endParaRPr lang="en-US" dirty="0"/>
           </a:p>
@@ -2243,7 +2243,7 @@
                   <a:schemeClr val="accent4"/>
                 </a:solidFill>
               </a:rPr>
-              <a:t>Geocaching Map – Custom Tile Layers · v1.54.47</a:t>
+              <a:t>Geocaching Map – Custom Tile Layers · v1.54.50</a:t>
             </a:r>
             <a:endParaRPr lang="en-US" sz="1000" dirty="0"/>
           </a:p>
@@ -2763,7 +2763,7 @@
                   <a:schemeClr val="accent5"/>
                 </a:solidFill>
               </a:rPr>
-              <a:t>Brukerskript · versjon 1.54.47 · norsk og engelsk</a:t>
+              <a:t>Brukerskript · versjon 1.54.50 · norsk og engelsk</a:t>
             </a:r>
             <a:endParaRPr lang="en-US" sz="1400" dirty="0"/>
           </a:p>
@@ -4165,7 +4165,7 @@
                   <a:schemeClr val="accent4"/>
                 </a:solidFill>
               </a:rPr>
-              <a:t>På dine korrigerte koordinater – også når ikonet er flyttet tilbake etter funn; et lite typeikon viser cachetypen</a:t>
+              <a:t>På dine korrigerte koordinater – også når ikonet er flyttet tilbake etter funn; et lite typeikon kan vise cachetypen</a:t>
             </a:r>
             <a:endParaRPr lang="en-US" sz="1700" dirty="0"/>
           </a:p>

</xml_diff>

<commit_message>
1.54.53 – Solved caches you have found get a smiley mark the size of the site's found icon (green tick kept); the marks button works on its own, also with the circles on; Route and the cache list buttons show a green edge while open; guides and presentations updated
</commit_message>
<xml_diff>
--- a/docs/Geocaching-Map-Custom-Tile-Layers-Presentasjon.pptx
+++ b/docs/Geocaching-Map-Custom-Tile-Layers-Presentasjon.pptx
@@ -123,13 +123,13 @@
   <p:extLst>
     <p:ext uri="{521415D9-36F7-43E2-AB2F-B90AF26B5E84}">
       <p14:sectionLst xmlns:p14="http://schemas.microsoft.com/office/powerpoint/2010/main">
-        <p14:section name="Innledning" id="{998e2ce4-f795-310a-0ea3-60e9b422603c}">
+        <p14:section name="Innledning" id="{809bc68a-0bcd-47e5-8916-e9c8287e0ce0}">
           <p14:sldIdLst>
             <p14:sldId id="256"/>
             <p14:sldId id="257"/>
           </p14:sldIdLst>
         </p14:section>
-        <p14:section name="Funksjoner" id="{5b88f283-1f68-0961-5b54-cf471a5e2568}">
+        <p14:section name="Funksjoner" id="{11639fc2-d133-50f3-2f66-0719410ab1c6}">
           <p14:sldIdLst>
             <p14:sldId id="258"/>
             <p14:sldId id="259"/>
@@ -144,14 +144,14 @@
             <p14:sldId id="268"/>
           </p14:sldIdLst>
         </p14:section>
-        <p14:section name="Teknikk" id="{46e4f3be-e0b2-d555-7dd8-46582cf16c9d}">
+        <p14:section name="Teknikk" id="{2b0b941b-33d9-23b6-29ee-d21eb20c4d0e}">
           <p14:sldIdLst>
             <p14:sldId id="269"/>
             <p14:sldId id="270"/>
             <p14:sldId id="271"/>
           </p14:sldIdLst>
         </p14:section>
-        <p14:section name="Avslutning" id="{5abb8aaa-4d3a-cc56-a622-bd4266de66a6}">
+        <p14:section name="Avslutning" id="{91947fc6-0f9a-a242-39ca-2393307d21b2}">
           <p14:sldIdLst>
             <p14:sldId id="272"/>
           </p14:sldIdLst>
@@ -824,7 +824,7 @@
           <a:p>
             <a:r>
               <a:rPr lang="en-US" dirty="0"/>
-              <a:t>Sirklene vises fra zoomnivå 15. Cachetypene, de nøyaktige koordinatene og dine løste koordinater kommer fra geocaching.coms eget cachesøk. Fysiske steg leses fra listen over tilleggsveipunkter på cachesiden – bare de eieren har gjort synlige. Blått merke med spørsmålstegn og grønn hake: en løst cache du har funnet. Liten blå prikk: fysisk steg. Liten grønn prikk: endelig plassering. Dine egne cacher, som cachesøket utelater, leses fra cachesidene; der beholdes nettstedets ikon og boble, men teksten ved musepekeren blir «Endelig plassering». Et lite typeikon kan vises nede til høyre på løste cacher – på nettstedets «løst»-ikon og på våre merker – siden «løst»-ikonet ikke viser cachetypen (Innstillinger, av som standard). Kartlagpanelet, søket og innstillingene åpnes der du sist dro dem.</a:t>
+              <a:t>Sirklene vises fra zoomnivå 15. Cachetypene, de nøyaktige koordinatene og dine løste koordinater kommer fra geocaching.coms eget cachesøk. Fysiske steg leses fra listen over tilleggsveipunkter på cachesiden – bare de eieren har gjort synlige. Gult smilefjes med grønn hake: en løst cache du har funnet. Blått merke med spørsmålstegn: en løst cache der ikonet ikke er på kartet. Liten blå prikk: fysisk steg. Liten grønn prikk: endelig plassering. Dine egne cacher, som cachesøket utelater, leses fra cachesidene; der beholdes nettstedets ikon og boble, men teksten ved musepekeren blir «Endelig plassering». Et lite typeikon kan vises nede til høyre på løste cacher – på nettstedets «løst»-ikon og på våre merker – siden «løst»-ikonet ikke viser cachetypen (Innstillinger, av som standard). Kartlagpanelet, søket og innstillingene åpnes der du sist dro dem.</a:t>
             </a:r>
             <a:endParaRPr lang="en-US" dirty="0"/>
           </a:p>
@@ -2243,7 +2243,7 @@
                   <a:schemeClr val="accent4"/>
                 </a:solidFill>
               </a:rPr>
-              <a:t>Geocaching Map – Custom Tile Layers · v1.54.50</a:t>
+              <a:t>Geocaching Map – Custom Tile Layers · v1.54.53</a:t>
             </a:r>
             <a:endParaRPr lang="en-US" sz="1000" dirty="0"/>
           </a:p>
@@ -2763,7 +2763,7 @@
                   <a:schemeClr val="accent5"/>
                 </a:solidFill>
               </a:rPr>
-              <a:t>Brukerskript · versjon 1.54.50 · norsk og engelsk</a:t>
+              <a:t>Brukerskript · versjon 1.54.53 · norsk og engelsk</a:t>
             </a:r>
             <a:endParaRPr lang="en-US" sz="1400" dirty="0"/>
           </a:p>

</xml_diff>